<commit_message>
Company profile v2: brand-only cover, 10 new venture logos, featured cases
- Cover rebuilt as brand-only (logo, wordmark, soft brand glows) with a
  commented one-line swap for a real office photo at
  public/profile-assets/office.jpg
- CEO photo removed from the leadership card (name/title/quote kept)
- Ventures grid uses pre-cropped tiles (public/profile-assets/) at the
  exact slide aspect — fixes stretched images — with corrected row
  spacing
- Case studies slide became "Featured Cases — our most recent & most
  creative work": Albina Alareeq, Nabe Eldiyafa, and new Diamond
  Events, each centered with its brand logo
- Brand wall expanded to 15 logos including the 10 new ventures
  (processed via the same auto-crop pipeline; Diamond Events needed a
  lower threshold for its pale gold text)

https://claude.ai/code/session_01ULuS7zriwA4qk6vRYb8xau
</commit_message>
<xml_diff>
--- a/public/WeThink-Company-Profile-2026.pptx
+++ b/public/WeThink-Company-Profile-2026.pptx
@@ -2045,9 +2045,84 @@
           <a:ln/>
         </p:spPr>
       </p:sp>
+      <p:sp>
+        <p:nvSpPr>
+          <p:cNvPr id="3" name="Shape 1"/>
+          <p:cNvSpPr/>
+          <p:nvPr/>
+        </p:nvSpPr>
+        <p:spPr>
+          <a:xfrm>
+            <a:off x="-2286000" y="-2560320"/>
+            <a:ext cx="6858000" cy="6858000"/>
+          </a:xfrm>
+          <a:prstGeom prst="ellipse">
+            <a:avLst/>
+          </a:prstGeom>
+          <a:solidFill>
+            <a:srgbClr val="14B8A6">
+              <a:alpha val="12000"/>
+            </a:srgbClr>
+          </a:solidFill>
+          <a:ln w="12700">
+            <a:solidFill>
+              <a:srgbClr val="333333">
+                <a:alpha val="0"/>
+              </a:srgbClr>
+            </a:solidFill>
+            <a:prstDash val="solid"/>
+          </a:ln>
+        </p:spPr>
+      </p:sp>
+      <p:sp>
+        <p:nvSpPr>
+          <p:cNvPr id="4" name="Shape 2"/>
+          <p:cNvSpPr/>
+          <p:nvPr/>
+        </p:nvSpPr>
+        <p:spPr>
+          <a:xfrm>
+            <a:off x="8229600" y="2560320"/>
+            <a:ext cx="7315200" cy="7315200"/>
+          </a:xfrm>
+          <a:prstGeom prst="ellipse">
+            <a:avLst/>
+          </a:prstGeom>
+          <a:solidFill>
+            <a:srgbClr val="7C3AED">
+              <a:alpha val="12000"/>
+            </a:srgbClr>
+          </a:solidFill>
+          <a:ln w="12700">
+            <a:solidFill>
+              <a:srgbClr val="333333">
+                <a:alpha val="0"/>
+              </a:srgbClr>
+            </a:solidFill>
+            <a:prstDash val="solid"/>
+          </a:ln>
+        </p:spPr>
+      </p:sp>
+      <p:sp>
+        <p:nvSpPr>
+          <p:cNvPr id="5" name="Shape 3"/>
+          <p:cNvSpPr/>
+          <p:nvPr/>
+        </p:nvSpPr>
+        <p:spPr>
+          <a:xfrm>
+            <a:off x="0" y="0"/>
+            <a:ext cx="12192000" cy="82296"/>
+          </a:xfrm>
+          <a:prstGeom prst="rect">
+            <a:avLst/>
+          </a:prstGeom>
+          <a:ln/>
+        </p:spPr>
+      </p:sp>
       <p:pic>
         <p:nvPicPr>
-          <p:cNvPr id="3" name="Image 0" descr="public/projects/nexa-pay.jpg">    </p:cNvPr>
+          <p:cNvPr id="6" name="Image 0" descr="public/logo.png">    </p:cNvPr>
           <p:cNvPicPr>
             <a:picLocks noChangeAspect="1"/>
           </p:cNvPicPr>
@@ -2055,76 +2130,14 @@
         </p:nvPicPr>
         <p:blipFill>
           <a:blip r:embed="rId1"/>
-          <a:srcRect l="0" r="0" t="0" b="0"/>
-          <a:stretch/>
-        </p:blipFill>
-        <p:spPr>
-          <a:xfrm>
-            <a:off x="0" y="0"/>
-            <a:ext cx="12188952" cy="6858000"/>
-          </a:xfrm>
-          <a:prstGeom prst="rect">
-            <a:avLst/>
-          </a:prstGeom>
-        </p:spPr>
-      </p:pic>
-      <p:sp>
-        <p:nvSpPr>
-          <p:cNvPr id="4" name="Shape 1"/>
-          <p:cNvSpPr/>
-          <p:nvPr/>
-        </p:nvSpPr>
-        <p:spPr>
-          <a:xfrm>
-            <a:off x="0" y="0"/>
-            <a:ext cx="12192000" cy="6858000"/>
-          </a:xfrm>
-          <a:prstGeom prst="rect">
-            <a:avLst/>
-          </a:prstGeom>
-          <a:solidFill>
-            <a:srgbClr val="0A1D21">
-              <a:alpha val="72000"/>
-            </a:srgbClr>
-          </a:solidFill>
-          <a:ln/>
-        </p:spPr>
-      </p:sp>
-      <p:sp>
-        <p:nvSpPr>
-          <p:cNvPr id="5" name="Shape 2"/>
-          <p:cNvSpPr/>
-          <p:nvPr/>
-        </p:nvSpPr>
-        <p:spPr>
-          <a:xfrm>
-            <a:off x="0" y="0"/>
-            <a:ext cx="12192000" cy="82296"/>
-          </a:xfrm>
-          <a:prstGeom prst="rect">
-            <a:avLst/>
-          </a:prstGeom>
-          <a:ln/>
-        </p:spPr>
-      </p:sp>
-      <p:pic>
-        <p:nvPicPr>
-          <p:cNvPr id="6" name="Image 1" descr="public/logo.png">    </p:cNvPr>
-          <p:cNvPicPr>
-            <a:picLocks noChangeAspect="1"/>
-          </p:cNvPicPr>
-          <p:nvPr/>
-        </p:nvPicPr>
-        <p:blipFill>
-          <a:blip r:embed="rId2"/>
           <a:stretch>
             <a:fillRect/>
           </a:stretch>
         </p:blipFill>
         <p:spPr>
           <a:xfrm>
-            <a:off x="548640" y="457200"/>
-            <a:ext cx="546811" cy="546811"/>
+            <a:off x="5408676" y="1051560"/>
+            <a:ext cx="1371600" cy="1371600"/>
           </a:xfrm>
           <a:prstGeom prst="rect">
             <a:avLst/>
@@ -2133,30 +2146,30 @@
       </p:pic>
       <p:sp>
         <p:nvSpPr>
-          <p:cNvPr id="7" name="Text 3"/>
-          <p:cNvSpPr/>
-          <p:nvPr/>
-        </p:nvSpPr>
-        <p:spPr>
-          <a:xfrm>
-            <a:off x="1126998" y="415138"/>
-            <a:ext cx="1892808" cy="420624"/>
-          </a:xfrm>
-          <a:prstGeom prst="rect">
-            <a:avLst/>
-          </a:prstGeom>
-          <a:noFill/>
-          <a:ln/>
-        </p:spPr>
-        <p:txBody>
-          <a:bodyPr wrap="square" rtlCol="0" anchor="ctr"/>
-          <a:lstStyle/>
-          <a:p>
-            <a:pPr indent="0" marL="0">
-              <a:buNone/>
-            </a:pPr>
-            <a:r>
-              <a:rPr lang="en-US" sz="1955" b="1" dirty="0">
+          <p:cNvPr id="7" name="Text 4"/>
+          <p:cNvSpPr/>
+          <p:nvPr/>
+        </p:nvSpPr>
+        <p:spPr>
+          <a:xfrm>
+            <a:off x="0" y="2514600"/>
+            <a:ext cx="12188952" cy="640080"/>
+          </a:xfrm>
+          <a:prstGeom prst="rect">
+            <a:avLst/>
+          </a:prstGeom>
+          <a:noFill/>
+          <a:ln/>
+        </p:spPr>
+        <p:txBody>
+          <a:bodyPr wrap="square" rtlCol="0" anchor="ctr"/>
+          <a:lstStyle/>
+          <a:p>
+            <a:pPr algn="ctr" indent="0" marL="0">
+              <a:buNone/>
+            </a:pPr>
+            <a:r>
+              <a:rPr lang="en-US" sz="4000" b="1" dirty="0">
                 <a:solidFill>
                   <a:srgbClr val="FFFFFF"/>
                 </a:solidFill>
@@ -2166,11 +2179,11 @@
               </a:rPr>
               <a:t>We</a:t>
             </a:r>
-            <a:pPr indent="0" marL="0">
-              <a:buNone/>
-            </a:pPr>
-            <a:r>
-              <a:rPr lang="en-US" sz="1955" b="1" dirty="0">
+            <a:pPr algn="ctr" indent="0" marL="0">
+              <a:buNone/>
+            </a:pPr>
+            <a:r>
+              <a:rPr lang="en-US" sz="4000" b="1" dirty="0">
                 <a:solidFill>
                   <a:srgbClr val="8B5CF6"/>
                 </a:solidFill>
@@ -2180,36 +2193,170 @@
               </a:rPr>
               <a:t>Think</a:t>
             </a:r>
-            <a:endParaRPr lang="en-US" sz="1955" dirty="0"/>
-          </a:p>
-        </p:txBody>
-      </p:sp>
-      <p:sp>
-        <p:nvSpPr>
-          <p:cNvPr id="8" name="Text 4"/>
-          <p:cNvSpPr/>
-          <p:nvPr/>
-        </p:nvSpPr>
-        <p:spPr>
-          <a:xfrm>
-            <a:off x="1148029" y="772668"/>
-            <a:ext cx="2103120" cy="252374"/>
-          </a:xfrm>
-          <a:prstGeom prst="rect">
-            <a:avLst/>
-          </a:prstGeom>
-          <a:noFill/>
-          <a:ln/>
-        </p:spPr>
-        <p:txBody>
-          <a:bodyPr wrap="square" rtlCol="0" anchor="ctr"/>
-          <a:lstStyle/>
-          <a:p>
-            <a:pPr indent="0" marL="0">
-              <a:buNone/>
-            </a:pPr>
-            <a:r>
-              <a:rPr lang="en-US" sz="748" spc="300" kern="0" dirty="0">
+            <a:endParaRPr lang="en-US" sz="4000" dirty="0"/>
+          </a:p>
+        </p:txBody>
+      </p:sp>
+      <p:sp>
+        <p:nvSpPr>
+          <p:cNvPr id="8" name="Text 5"/>
+          <p:cNvSpPr/>
+          <p:nvPr/>
+        </p:nvSpPr>
+        <p:spPr>
+          <a:xfrm>
+            <a:off x="0" y="3200400"/>
+            <a:ext cx="12188952" cy="320040"/>
+          </a:xfrm>
+          <a:prstGeom prst="rect">
+            <a:avLst/>
+          </a:prstGeom>
+          <a:noFill/>
+          <a:ln/>
+        </p:spPr>
+        <p:txBody>
+          <a:bodyPr wrap="square" rtlCol="0" anchor="ctr"/>
+          <a:lstStyle/>
+          <a:p>
+            <a:pPr algn="ctr" indent="0" marL="0">
+              <a:buNone/>
+            </a:pPr>
+            <a:r>
+              <a:rPr lang="en-US" sz="1100" spc="200" kern="0" dirty="0">
+                <a:solidFill>
+                  <a:srgbClr val="14B8A6"/>
+                </a:solidFill>
+                <a:latin typeface="Segoe UI" pitchFamily="34" charset="0"/>
+                <a:ea typeface="Segoe UI" pitchFamily="34" charset="-122"/>
+                <a:cs typeface="Segoe UI" pitchFamily="34" charset="-120"/>
+              </a:rPr>
+              <a:t>T H I N K   ·   P L A N   ·   G R O W</a:t>
+            </a:r>
+            <a:endParaRPr lang="en-US" sz="1100" dirty="0"/>
+          </a:p>
+        </p:txBody>
+      </p:sp>
+      <p:sp>
+        <p:nvSpPr>
+          <p:cNvPr id="9" name="Shape 6"/>
+          <p:cNvSpPr/>
+          <p:nvPr/>
+        </p:nvSpPr>
+        <p:spPr>
+          <a:xfrm>
+            <a:off x="5637276" y="3703320"/>
+            <a:ext cx="914400" cy="41148"/>
+          </a:xfrm>
+          <a:prstGeom prst="rect">
+            <a:avLst/>
+          </a:prstGeom>
+          <a:ln/>
+        </p:spPr>
+      </p:sp>
+      <p:sp>
+        <p:nvSpPr>
+          <p:cNvPr id="10" name="Text 7"/>
+          <p:cNvSpPr/>
+          <p:nvPr/>
+        </p:nvSpPr>
+        <p:spPr>
+          <a:xfrm>
+            <a:off x="0" y="3886200"/>
+            <a:ext cx="12188952" cy="777240"/>
+          </a:xfrm>
+          <a:prstGeom prst="rect">
+            <a:avLst/>
+          </a:prstGeom>
+          <a:noFill/>
+          <a:ln/>
+        </p:spPr>
+        <p:txBody>
+          <a:bodyPr wrap="square" rtlCol="0" anchor="ctr"/>
+          <a:lstStyle/>
+          <a:p>
+            <a:pPr algn="ctr" indent="0" marL="0">
+              <a:buNone/>
+            </a:pPr>
+            <a:r>
+              <a:rPr lang="en-US" sz="4400" b="1" dirty="0">
+                <a:solidFill>
+                  <a:srgbClr val="FFFFFF"/>
+                </a:solidFill>
+                <a:latin typeface="Segoe UI" pitchFamily="34" charset="0"/>
+                <a:ea typeface="Segoe UI" pitchFamily="34" charset="-122"/>
+                <a:cs typeface="Segoe UI" pitchFamily="34" charset="-120"/>
+              </a:rPr>
+              <a:t>Company Profile</a:t>
+            </a:r>
+            <a:endParaRPr lang="en-US" sz="4400" dirty="0"/>
+          </a:p>
+        </p:txBody>
+      </p:sp>
+      <p:sp>
+        <p:nvSpPr>
+          <p:cNvPr id="11" name="Text 8"/>
+          <p:cNvSpPr/>
+          <p:nvPr/>
+        </p:nvSpPr>
+        <p:spPr>
+          <a:xfrm>
+            <a:off x="0" y="4709160"/>
+            <a:ext cx="12188952" cy="411480"/>
+          </a:xfrm>
+          <a:prstGeom prst="rect">
+            <a:avLst/>
+          </a:prstGeom>
+          <a:noFill/>
+          <a:ln/>
+        </p:spPr>
+        <p:txBody>
+          <a:bodyPr wrap="square" rtlCol="0" anchor="ctr"/>
+          <a:lstStyle/>
+          <a:p>
+            <a:pPr algn="ctr" indent="0" marL="0">
+              <a:buNone/>
+            </a:pPr>
+            <a:r>
+              <a:rPr lang="en-US" sz="1700" dirty="0">
+                <a:solidFill>
+                  <a:srgbClr val="D9E6E4"/>
+                </a:solidFill>
+                <a:latin typeface="Segoe UI" pitchFamily="34" charset="0"/>
+                <a:ea typeface="Segoe UI" pitchFamily="34" charset="-122"/>
+                <a:cs typeface="Segoe UI" pitchFamily="34" charset="-120"/>
+              </a:rPr>
+              <a:t>Your Digital Transformation Partner</a:t>
+            </a:r>
+            <a:endParaRPr lang="en-US" sz="1700" dirty="0"/>
+          </a:p>
+        </p:txBody>
+      </p:sp>
+      <p:sp>
+        <p:nvSpPr>
+          <p:cNvPr id="12" name="Text 9"/>
+          <p:cNvSpPr/>
+          <p:nvPr/>
+        </p:nvSpPr>
+        <p:spPr>
+          <a:xfrm>
+            <a:off x="0" y="5138928"/>
+            <a:ext cx="12188952" cy="320040"/>
+          </a:xfrm>
+          <a:prstGeom prst="rect">
+            <a:avLst/>
+          </a:prstGeom>
+          <a:noFill/>
+          <a:ln/>
+        </p:spPr>
+        <p:txBody>
+          <a:bodyPr wrap="square" rtlCol="0" anchor="ctr"/>
+          <a:lstStyle/>
+          <a:p>
+            <a:pPr algn="ctr" indent="0" marL="0">
+              <a:buNone/>
+            </a:pPr>
+            <a:r>
+              <a:rPr lang="en-US" sz="1200" dirty="0">
                 <a:solidFill>
                   <a:srgbClr val="9FB8B4"/>
                 </a:solidFill>
@@ -2217,194 +2364,15 @@
                 <a:ea typeface="Segoe UI" pitchFamily="34" charset="-122"/>
                 <a:cs typeface="Segoe UI" pitchFamily="34" charset="-120"/>
               </a:rPr>
-              <a:t>THINK · PLAN · GROW</a:t>
-            </a:r>
-            <a:endParaRPr lang="en-US" sz="748" dirty="0"/>
-          </a:p>
-        </p:txBody>
-      </p:sp>
-      <p:sp>
-        <p:nvSpPr>
-          <p:cNvPr id="9" name="Shape 5"/>
-          <p:cNvSpPr/>
-          <p:nvPr/>
-        </p:nvSpPr>
-        <p:spPr>
-          <a:xfrm>
-            <a:off x="960120" y="2788920"/>
-            <a:ext cx="25603" cy="1828800"/>
-          </a:xfrm>
-          <a:prstGeom prst="rect">
-            <a:avLst/>
-          </a:prstGeom>
-          <a:solidFill>
-            <a:srgbClr val="FFFFFF">
-              <a:alpha val="70000"/>
-            </a:srgbClr>
-          </a:solidFill>
-          <a:ln/>
-        </p:spPr>
-      </p:sp>
-      <p:sp>
-        <p:nvSpPr>
-          <p:cNvPr id="10" name="Text 6"/>
-          <p:cNvSpPr/>
-          <p:nvPr/>
-        </p:nvSpPr>
-        <p:spPr>
-          <a:xfrm>
-            <a:off x="1234440" y="2697480"/>
-            <a:ext cx="6858000" cy="1600200"/>
-          </a:xfrm>
-          <a:prstGeom prst="rect">
-            <a:avLst/>
-          </a:prstGeom>
-          <a:noFill/>
-          <a:ln/>
-        </p:spPr>
-        <p:txBody>
-          <a:bodyPr wrap="square" rtlCol="0" anchor="ctr"/>
-          <a:lstStyle/>
-          <a:p>
-            <a:pPr indent="0" marL="0">
-              <a:lnSpc>
-                <a:spcPts val="5200"/>
-              </a:lnSpc>
-              <a:buNone/>
-            </a:pPr>
-            <a:r>
-              <a:rPr lang="en-US" sz="4600" b="1" dirty="0">
-                <a:solidFill>
-                  <a:srgbClr val="FFFFFF"/>
-                </a:solidFill>
-                <a:latin typeface="Segoe UI" pitchFamily="34" charset="0"/>
-                <a:ea typeface="Segoe UI" pitchFamily="34" charset="-122"/>
-                <a:cs typeface="Segoe UI" pitchFamily="34" charset="-120"/>
-              </a:rPr>
-              <a:t>Company</a:t>
-            </a:r>
-            <a:endParaRPr lang="en-US" sz="4600" dirty="0"/>
-          </a:p>
-          <a:p>
-            <a:pPr indent="0" marL="0">
-              <a:lnSpc>
-                <a:spcPts val="5200"/>
-              </a:lnSpc>
-              <a:buNone/>
-            </a:pPr>
-            <a:r>
-              <a:rPr lang="en-US" sz="4600" b="1" dirty="0">
-                <a:solidFill>
-                  <a:srgbClr val="FFFFFF"/>
-                </a:solidFill>
-                <a:latin typeface="Segoe UI" pitchFamily="34" charset="0"/>
-                <a:ea typeface="Segoe UI" pitchFamily="34" charset="-122"/>
-                <a:cs typeface="Segoe UI" pitchFamily="34" charset="-120"/>
-              </a:rPr>
-              <a:t>Profile</a:t>
-            </a:r>
-            <a:endParaRPr lang="en-US" sz="4600" dirty="0"/>
-          </a:p>
-        </p:txBody>
-      </p:sp>
-      <p:sp>
-        <p:nvSpPr>
-          <p:cNvPr id="11" name="Shape 7"/>
-          <p:cNvSpPr/>
-          <p:nvPr/>
-        </p:nvSpPr>
-        <p:spPr>
-          <a:xfrm>
-            <a:off x="1261872" y="4480560"/>
-            <a:ext cx="128016" cy="384048"/>
-          </a:xfrm>
-          <a:prstGeom prst="rect">
-            <a:avLst/>
-          </a:prstGeom>
-          <a:ln/>
-        </p:spPr>
-      </p:sp>
-      <p:sp>
-        <p:nvSpPr>
-          <p:cNvPr id="12" name="Text 8"/>
-          <p:cNvSpPr/>
-          <p:nvPr/>
-        </p:nvSpPr>
-        <p:spPr>
-          <a:xfrm>
-            <a:off x="1481328" y="4453128"/>
-            <a:ext cx="7772400" cy="411480"/>
-          </a:xfrm>
-          <a:prstGeom prst="rect">
-            <a:avLst/>
-          </a:prstGeom>
-          <a:noFill/>
-          <a:ln/>
-        </p:spPr>
-        <p:txBody>
-          <a:bodyPr wrap="square" rtlCol="0" anchor="ctr"/>
-          <a:lstStyle/>
-          <a:p>
-            <a:pPr indent="0" marL="0">
-              <a:buNone/>
-            </a:pPr>
-            <a:r>
-              <a:rPr lang="en-US" sz="2000" dirty="0">
-                <a:solidFill>
-                  <a:srgbClr val="FFFFFF"/>
-                </a:solidFill>
-                <a:latin typeface="Segoe UI" pitchFamily="34" charset="0"/>
-                <a:ea typeface="Segoe UI" pitchFamily="34" charset="-122"/>
-                <a:cs typeface="Segoe UI" pitchFamily="34" charset="-120"/>
-              </a:rPr>
-              <a:t>Your Digital Transformation Partner</a:t>
-            </a:r>
-            <a:endParaRPr lang="en-US" sz="2000" dirty="0"/>
-          </a:p>
-        </p:txBody>
-      </p:sp>
-      <p:sp>
-        <p:nvSpPr>
-          <p:cNvPr id="13" name="Text 9"/>
-          <p:cNvSpPr/>
-          <p:nvPr/>
-        </p:nvSpPr>
-        <p:spPr>
-          <a:xfrm>
-            <a:off x="1481328" y="4892040"/>
-            <a:ext cx="8686800" cy="320040"/>
-          </a:xfrm>
-          <a:prstGeom prst="rect">
-            <a:avLst/>
-          </a:prstGeom>
-          <a:noFill/>
-          <a:ln/>
-        </p:spPr>
-        <p:txBody>
-          <a:bodyPr wrap="square" rtlCol="0" anchor="ctr"/>
-          <a:lstStyle/>
-          <a:p>
-            <a:pPr indent="0" marL="0">
-              <a:buNone/>
-            </a:pPr>
-            <a:r>
-              <a:rPr lang="en-US" sz="1250" dirty="0">
-                <a:solidFill>
-                  <a:srgbClr val="D9E6E4"/>
-                </a:solidFill>
-                <a:latin typeface="Segoe UI" pitchFamily="34" charset="0"/>
-                <a:ea typeface="Segoe UI" pitchFamily="34" charset="-122"/>
-                <a:cs typeface="Segoe UI" pitchFamily="34" charset="-120"/>
-              </a:rPr>
               <a:t>Consulting  –  Cloud  –  Cybersecurity  –  Custom Software  –  Data &amp; AI</a:t>
             </a:r>
-            <a:endParaRPr lang="en-US" sz="1250" dirty="0"/>
-          </a:p>
-        </p:txBody>
-      </p:sp>
-      <p:sp>
-        <p:nvSpPr>
-          <p:cNvPr id="14" name="Text 10"/>
+            <a:endParaRPr lang="en-US" sz="1200" dirty="0"/>
+          </a:p>
+        </p:txBody>
+      </p:sp>
+      <p:sp>
+        <p:nvSpPr>
+          <p:cNvPr id="13" name="Text 10"/>
           <p:cNvSpPr/>
           <p:nvPr/>
         </p:nvSpPr>
@@ -2443,7 +2411,7 @@
       </p:sp>
       <p:sp>
         <p:nvSpPr>
-          <p:cNvPr id="15" name="Text 11"/>
+          <p:cNvPr id="14" name="Text 11"/>
           <p:cNvSpPr/>
           <p:nvPr/>
         </p:nvSpPr>
@@ -8491,7 +8459,7 @@
                 <a:ea typeface="Segoe UI" pitchFamily="34" charset="-122"/>
                 <a:cs typeface="Segoe UI" pitchFamily="34" charset="-120"/>
               </a:rPr>
-              <a:t>Identities we designed and launched through the pre-launch venture programme — English and Arabic, across fintech, retail, wellness, F&amp;B, fragrance, and real estate.</a:t>
+              <a:t>Identities we designed and launched — English and Arabic, across fintech, logistics, retail, wellness, F&amp;B, media, events, and more.</a:t>
             </a:r>
             <a:endParaRPr lang="en-US" sz="1100" dirty="0"/>
           </a:p>
@@ -8505,12 +8473,12 @@
         </p:nvSpPr>
         <p:spPr>
           <a:xfrm>
-            <a:off x="502920" y="1828800"/>
-            <a:ext cx="2658618" cy="1737360"/>
+            <a:off x="512064" y="1746504"/>
+            <a:ext cx="2108606" cy="1389888"/>
           </a:xfrm>
           <a:prstGeom prst="roundRect">
             <a:avLst>
-              <a:gd name="adj" fmla="val 4211"/>
+              <a:gd name="adj" fmla="val 4605"/>
             </a:avLst>
           </a:prstGeom>
           <a:solidFill>
@@ -8534,13 +8502,14 @@
         </p:nvPicPr>
         <p:blipFill>
           <a:blip r:embed="rId1"/>
-          <a:srcRect l="0" r="0" t="0" b="0"/>
-          <a:stretch/>
+          <a:stretch>
+            <a:fillRect/>
+          </a:stretch>
         </p:blipFill>
         <p:spPr>
           <a:xfrm>
-            <a:off x="868680" y="1984248"/>
-            <a:ext cx="1927098" cy="1156259"/>
+            <a:off x="804672" y="1856232"/>
+            <a:ext cx="1523390" cy="914034"/>
           </a:xfrm>
           <a:prstGeom prst="rect">
             <a:avLst/>
@@ -8555,8 +8524,8 @@
         </p:nvSpPr>
         <p:spPr>
           <a:xfrm>
-            <a:off x="502920" y="3200400"/>
-            <a:ext cx="2658618" cy="274320"/>
+            <a:off x="512064" y="2825496"/>
+            <a:ext cx="2108606" cy="256032"/>
           </a:xfrm>
           <a:prstGeom prst="rect">
             <a:avLst/>
@@ -8572,7 +8541,7 @@
               <a:buNone/>
             </a:pPr>
             <a:r>
-              <a:rPr lang="en-US" sz="950" b="1" dirty="0">
+              <a:rPr lang="en-US" sz="800" b="1" dirty="0">
                 <a:solidFill>
                   <a:srgbClr val="10232E"/>
                 </a:solidFill>
@@ -8582,7 +8551,7 @@
               </a:rPr>
               <a:t>Nexa Pay · Fintech</a:t>
             </a:r>
-            <a:endParaRPr lang="en-US" sz="950" dirty="0"/>
+            <a:endParaRPr lang="en-US" sz="800" dirty="0"/>
           </a:p>
         </p:txBody>
       </p:sp>
@@ -8594,12 +8563,12 @@
         </p:nvSpPr>
         <p:spPr>
           <a:xfrm>
-            <a:off x="3344418" y="1828800"/>
-            <a:ext cx="2658618" cy="1737360"/>
+            <a:off x="2776118" y="1746504"/>
+            <a:ext cx="2108606" cy="1389888"/>
           </a:xfrm>
           <a:prstGeom prst="roundRect">
             <a:avLst>
-              <a:gd name="adj" fmla="val 4211"/>
+              <a:gd name="adj" fmla="val 4605"/>
             </a:avLst>
           </a:prstGeom>
           <a:solidFill>
@@ -8623,13 +8592,14 @@
         </p:nvPicPr>
         <p:blipFill>
           <a:blip r:embed="rId2"/>
-          <a:srcRect l="0" r="0" t="0" b="0"/>
-          <a:stretch/>
+          <a:stretch>
+            <a:fillRect/>
+          </a:stretch>
         </p:blipFill>
         <p:spPr>
           <a:xfrm>
-            <a:off x="3710178" y="1984248"/>
-            <a:ext cx="1927098" cy="1156259"/>
+            <a:off x="3068726" y="1856232"/>
+            <a:ext cx="1523390" cy="914034"/>
           </a:xfrm>
           <a:prstGeom prst="rect">
             <a:avLst/>
@@ -8644,8 +8614,8 @@
         </p:nvSpPr>
         <p:spPr>
           <a:xfrm>
-            <a:off x="3344418" y="3200400"/>
-            <a:ext cx="2658618" cy="274320"/>
+            <a:off x="2776118" y="2825496"/>
+            <a:ext cx="2108606" cy="256032"/>
           </a:xfrm>
           <a:prstGeom prst="rect">
             <a:avLst/>
@@ -8661,7 +8631,7 @@
               <a:buNone/>
             </a:pPr>
             <a:r>
-              <a:rPr lang="en-US" sz="950" b="1" dirty="0">
+              <a:rPr lang="en-US" sz="800" b="1" dirty="0">
                 <a:solidFill>
                   <a:srgbClr val="10232E"/>
                 </a:solidFill>
@@ -8671,7 +8641,7 @@
               </a:rPr>
               <a:t>CargoFlow · Logistics</a:t>
             </a:r>
-            <a:endParaRPr lang="en-US" sz="950" dirty="0"/>
+            <a:endParaRPr lang="en-US" sz="800" dirty="0"/>
           </a:p>
         </p:txBody>
       </p:sp>
@@ -8683,12 +8653,12 @@
         </p:nvSpPr>
         <p:spPr>
           <a:xfrm>
-            <a:off x="6185916" y="1828800"/>
-            <a:ext cx="2658618" cy="1737360"/>
+            <a:off x="5040173" y="1746504"/>
+            <a:ext cx="2108606" cy="1389888"/>
           </a:xfrm>
           <a:prstGeom prst="roundRect">
             <a:avLst>
-              <a:gd name="adj" fmla="val 4211"/>
+              <a:gd name="adj" fmla="val 4605"/>
             </a:avLst>
           </a:prstGeom>
           <a:solidFill>
@@ -8712,13 +8682,14 @@
         </p:nvPicPr>
         <p:blipFill>
           <a:blip r:embed="rId3"/>
-          <a:srcRect l="0" r="0" t="0" b="0"/>
-          <a:stretch/>
+          <a:stretch>
+            <a:fillRect/>
+          </a:stretch>
         </p:blipFill>
         <p:spPr>
           <a:xfrm>
-            <a:off x="6551676" y="1984248"/>
-            <a:ext cx="1927098" cy="1156259"/>
+            <a:off x="5332781" y="1856232"/>
+            <a:ext cx="1523390" cy="914034"/>
           </a:xfrm>
           <a:prstGeom prst="rect">
             <a:avLst/>
@@ -8733,8 +8704,8 @@
         </p:nvSpPr>
         <p:spPr>
           <a:xfrm>
-            <a:off x="6185916" y="3200400"/>
-            <a:ext cx="2658618" cy="274320"/>
+            <a:off x="5040173" y="2825496"/>
+            <a:ext cx="2108606" cy="256032"/>
           </a:xfrm>
           <a:prstGeom prst="rect">
             <a:avLst/>
@@ -8750,7 +8721,7 @@
               <a:buNone/>
             </a:pPr>
             <a:r>
-              <a:rPr lang="en-US" sz="950" b="1" dirty="0">
+              <a:rPr lang="en-US" sz="800" b="1" dirty="0">
                 <a:solidFill>
                   <a:srgbClr val="10232E"/>
                 </a:solidFill>
@@ -8760,7 +8731,7 @@
               </a:rPr>
               <a:t>Lumora · Skincare</a:t>
             </a:r>
-            <a:endParaRPr lang="en-US" sz="950" dirty="0"/>
+            <a:endParaRPr lang="en-US" sz="800" dirty="0"/>
           </a:p>
         </p:txBody>
       </p:sp>
@@ -8772,12 +8743,12 @@
         </p:nvSpPr>
         <p:spPr>
           <a:xfrm>
-            <a:off x="9027414" y="1828800"/>
-            <a:ext cx="2658618" cy="1737360"/>
+            <a:off x="7304227" y="1746504"/>
+            <a:ext cx="2108606" cy="1389888"/>
           </a:xfrm>
           <a:prstGeom prst="roundRect">
             <a:avLst>
-              <a:gd name="adj" fmla="val 4211"/>
+              <a:gd name="adj" fmla="val 4605"/>
             </a:avLst>
           </a:prstGeom>
           <a:solidFill>
@@ -8801,13 +8772,14 @@
         </p:nvPicPr>
         <p:blipFill>
           <a:blip r:embed="rId4"/>
-          <a:srcRect l="0" r="0" t="0" b="0"/>
-          <a:stretch/>
+          <a:stretch>
+            <a:fillRect/>
+          </a:stretch>
         </p:blipFill>
         <p:spPr>
           <a:xfrm>
-            <a:off x="9393174" y="1984248"/>
-            <a:ext cx="1927098" cy="1156259"/>
+            <a:off x="7596835" y="1856232"/>
+            <a:ext cx="1523390" cy="914034"/>
           </a:xfrm>
           <a:prstGeom prst="rect">
             <a:avLst/>
@@ -8822,8 +8794,8 @@
         </p:nvSpPr>
         <p:spPr>
           <a:xfrm>
-            <a:off x="9027414" y="3200400"/>
-            <a:ext cx="2658618" cy="274320"/>
+            <a:off x="7304227" y="2825496"/>
+            <a:ext cx="2108606" cy="256032"/>
           </a:xfrm>
           <a:prstGeom prst="rect">
             <a:avLst/>
@@ -8839,7 +8811,7 @@
               <a:buNone/>
             </a:pPr>
             <a:r>
-              <a:rPr lang="en-US" sz="950" b="1" dirty="0">
+              <a:rPr lang="en-US" sz="800" b="1" dirty="0">
                 <a:solidFill>
                   <a:srgbClr val="10232E"/>
                 </a:solidFill>
@@ -8849,7 +8821,7 @@
               </a:rPr>
               <a:t>Pulse Loop · Wellness</a:t>
             </a:r>
-            <a:endParaRPr lang="en-US" sz="950" dirty="0"/>
+            <a:endParaRPr lang="en-US" sz="800" dirty="0"/>
           </a:p>
         </p:txBody>
       </p:sp>
@@ -8861,12 +8833,12 @@
         </p:nvSpPr>
         <p:spPr>
           <a:xfrm>
-            <a:off x="502920" y="3931920"/>
-            <a:ext cx="2658618" cy="1737360"/>
+            <a:off x="9568282" y="1746504"/>
+            <a:ext cx="2108606" cy="1389888"/>
           </a:xfrm>
           <a:prstGeom prst="roundRect">
             <a:avLst>
-              <a:gd name="adj" fmla="val 4211"/>
+              <a:gd name="adj" fmla="val 4605"/>
             </a:avLst>
           </a:prstGeom>
           <a:solidFill>
@@ -8882,7 +8854,7 @@
       </p:sp>
       <p:pic>
         <p:nvPicPr>
-          <p:cNvPr id="20" name="Image 4" descr="public/logos/qahwat-al-asala.png">    </p:cNvPr>
+          <p:cNvPr id="20" name="Image 4" descr="public/logos/satrek-fashion.png">    </p:cNvPr>
           <p:cNvPicPr>
             <a:picLocks noChangeAspect="1"/>
           </p:cNvPicPr>
@@ -8890,13 +8862,14 @@
         </p:nvPicPr>
         <p:blipFill>
           <a:blip r:embed="rId5"/>
-          <a:srcRect l="0" r="0" t="0" b="0"/>
-          <a:stretch/>
+          <a:stretch>
+            <a:fillRect/>
+          </a:stretch>
         </p:blipFill>
         <p:spPr>
           <a:xfrm>
-            <a:off x="868680" y="4087368"/>
-            <a:ext cx="1927098" cy="1156259"/>
+            <a:off x="9860890" y="1856232"/>
+            <a:ext cx="1523390" cy="914034"/>
           </a:xfrm>
           <a:prstGeom prst="rect">
             <a:avLst/>
@@ -8911,8 +8884,8 @@
         </p:nvSpPr>
         <p:spPr>
           <a:xfrm>
-            <a:off x="502920" y="5303520"/>
-            <a:ext cx="2658618" cy="274320"/>
+            <a:off x="9568282" y="2825496"/>
+            <a:ext cx="2108606" cy="256032"/>
           </a:xfrm>
           <a:prstGeom prst="rect">
             <a:avLst/>
@@ -8928,7 +8901,7 @@
               <a:buNone/>
             </a:pPr>
             <a:r>
-              <a:rPr lang="en-US" sz="950" b="1" dirty="0">
+              <a:rPr lang="en-US" sz="800" b="1" dirty="0">
                 <a:solidFill>
                   <a:srgbClr val="10232E"/>
                 </a:solidFill>
@@ -8936,9 +8909,9 @@
                 <a:ea typeface="Segoe UI" pitchFamily="34" charset="-122"/>
                 <a:cs typeface="Segoe UI" pitchFamily="34" charset="-120"/>
               </a:rPr>
-              <a:t>قهوة الأصالة · Café</a:t>
-            </a:r>
-            <a:endParaRPr lang="en-US" sz="950" dirty="0"/>
+              <a:t>سترك · Fashion</a:t>
+            </a:r>
+            <a:endParaRPr lang="en-US" sz="800" dirty="0"/>
           </a:p>
         </p:txBody>
       </p:sp>
@@ -8950,12 +8923,12 @@
         </p:nvSpPr>
         <p:spPr>
           <a:xfrm>
-            <a:off x="3344418" y="3931920"/>
-            <a:ext cx="2658618" cy="1737360"/>
+            <a:off x="512064" y="3282696"/>
+            <a:ext cx="2108606" cy="1389888"/>
           </a:xfrm>
           <a:prstGeom prst="roundRect">
             <a:avLst>
-              <a:gd name="adj" fmla="val 4211"/>
+              <a:gd name="adj" fmla="val 4605"/>
             </a:avLst>
           </a:prstGeom>
           <a:solidFill>
@@ -8971,7 +8944,7 @@
       </p:sp>
       <p:pic>
         <p:nvPicPr>
-          <p:cNvPr id="23" name="Image 5" descr="public/logos/anmat.png">    </p:cNvPr>
+          <p:cNvPr id="23" name="Image 5" descr="public/logos/qahwat-al-asala.png">    </p:cNvPr>
           <p:cNvPicPr>
             <a:picLocks noChangeAspect="1"/>
           </p:cNvPicPr>
@@ -8979,13 +8952,14 @@
         </p:nvPicPr>
         <p:blipFill>
           <a:blip r:embed="rId6"/>
-          <a:srcRect l="0" r="0" t="0" b="0"/>
-          <a:stretch/>
+          <a:stretch>
+            <a:fillRect/>
+          </a:stretch>
         </p:blipFill>
         <p:spPr>
           <a:xfrm>
-            <a:off x="3710178" y="4087368"/>
-            <a:ext cx="1927098" cy="1156259"/>
+            <a:off x="804672" y="3392424"/>
+            <a:ext cx="1523390" cy="914034"/>
           </a:xfrm>
           <a:prstGeom prst="rect">
             <a:avLst/>
@@ -9000,8 +8974,8 @@
         </p:nvSpPr>
         <p:spPr>
           <a:xfrm>
-            <a:off x="3344418" y="5303520"/>
-            <a:ext cx="2658618" cy="274320"/>
+            <a:off x="512064" y="4361688"/>
+            <a:ext cx="2108606" cy="256032"/>
           </a:xfrm>
           <a:prstGeom prst="rect">
             <a:avLst/>
@@ -9017,7 +8991,7 @@
               <a:buNone/>
             </a:pPr>
             <a:r>
-              <a:rPr lang="en-US" sz="950" b="1" dirty="0">
+              <a:rPr lang="en-US" sz="800" b="1" dirty="0">
                 <a:solidFill>
                   <a:srgbClr val="10232E"/>
                 </a:solidFill>
@@ -9025,9 +8999,9 @@
                 <a:ea typeface="Segoe UI" pitchFamily="34" charset="-122"/>
                 <a:cs typeface="Segoe UI" pitchFamily="34" charset="-120"/>
               </a:rPr>
-              <a:t>أنماط · Fashion</a:t>
-            </a:r>
-            <a:endParaRPr lang="en-US" sz="950" dirty="0"/>
+              <a:t>قهوة الأصالة · Café</a:t>
+            </a:r>
+            <a:endParaRPr lang="en-US" sz="800" dirty="0"/>
           </a:p>
         </p:txBody>
       </p:sp>
@@ -9039,12 +9013,12 @@
         </p:nvSpPr>
         <p:spPr>
           <a:xfrm>
-            <a:off x="6185916" y="3931920"/>
-            <a:ext cx="2658618" cy="1737360"/>
+            <a:off x="2776118" y="3282696"/>
+            <a:ext cx="2108606" cy="1389888"/>
           </a:xfrm>
           <a:prstGeom prst="roundRect">
             <a:avLst>
-              <a:gd name="adj" fmla="val 4211"/>
+              <a:gd name="adj" fmla="val 4605"/>
             </a:avLst>
           </a:prstGeom>
           <a:solidFill>
@@ -9060,7 +9034,7 @@
       </p:sp>
       <p:pic>
         <p:nvPicPr>
-          <p:cNvPr id="26" name="Image 6" descr="public/logos/abeer-al-diyar.png">    </p:cNvPr>
+          <p:cNvPr id="26" name="Image 6" descr="public/logos/anmat.png">    </p:cNvPr>
           <p:cNvPicPr>
             <a:picLocks noChangeAspect="1"/>
           </p:cNvPicPr>
@@ -9068,13 +9042,14 @@
         </p:nvPicPr>
         <p:blipFill>
           <a:blip r:embed="rId7"/>
-          <a:srcRect l="0" r="0" t="0" b="0"/>
-          <a:stretch/>
+          <a:stretch>
+            <a:fillRect/>
+          </a:stretch>
         </p:blipFill>
         <p:spPr>
           <a:xfrm>
-            <a:off x="6551676" y="4087368"/>
-            <a:ext cx="1927098" cy="1156259"/>
+            <a:off x="3068726" y="3392424"/>
+            <a:ext cx="1523390" cy="914034"/>
           </a:xfrm>
           <a:prstGeom prst="rect">
             <a:avLst/>
@@ -9089,8 +9064,8 @@
         </p:nvSpPr>
         <p:spPr>
           <a:xfrm>
-            <a:off x="6185916" y="5303520"/>
-            <a:ext cx="2658618" cy="274320"/>
+            <a:off x="2776118" y="4361688"/>
+            <a:ext cx="2108606" cy="256032"/>
           </a:xfrm>
           <a:prstGeom prst="rect">
             <a:avLst/>
@@ -9106,7 +9081,7 @@
               <a:buNone/>
             </a:pPr>
             <a:r>
-              <a:rPr lang="en-US" sz="950" b="1" dirty="0">
+              <a:rPr lang="en-US" sz="800" b="1" dirty="0">
                 <a:solidFill>
                   <a:srgbClr val="10232E"/>
                 </a:solidFill>
@@ -9114,9 +9089,9 @@
                 <a:ea typeface="Segoe UI" pitchFamily="34" charset="-122"/>
                 <a:cs typeface="Segoe UI" pitchFamily="34" charset="-120"/>
               </a:rPr>
-              <a:t>عبير الديار · Fragrance</a:t>
-            </a:r>
-            <a:endParaRPr lang="en-US" sz="950" dirty="0"/>
+              <a:t>أنماط · Fashion</a:t>
+            </a:r>
+            <a:endParaRPr lang="en-US" sz="800" dirty="0"/>
           </a:p>
         </p:txBody>
       </p:sp>
@@ -9128,12 +9103,12 @@
         </p:nvSpPr>
         <p:spPr>
           <a:xfrm>
-            <a:off x="9027414" y="3931920"/>
-            <a:ext cx="2658618" cy="1737360"/>
+            <a:off x="5040173" y="3282696"/>
+            <a:ext cx="2108606" cy="1389888"/>
           </a:xfrm>
           <a:prstGeom prst="roundRect">
             <a:avLst>
-              <a:gd name="adj" fmla="val 4211"/>
+              <a:gd name="adj" fmla="val 4605"/>
             </a:avLst>
           </a:prstGeom>
           <a:solidFill>
@@ -9149,7 +9124,7 @@
       </p:sp>
       <p:pic>
         <p:nvPicPr>
-          <p:cNvPr id="29" name="Image 7" descr="public/logos/masaken.png">    </p:cNvPr>
+          <p:cNvPr id="29" name="Image 7" descr="public/logos/abeer-al-diyar.png">    </p:cNvPr>
           <p:cNvPicPr>
             <a:picLocks noChangeAspect="1"/>
           </p:cNvPicPr>
@@ -9157,13 +9132,14 @@
         </p:nvPicPr>
         <p:blipFill>
           <a:blip r:embed="rId8"/>
-          <a:srcRect l="0" r="0" t="0" b="0"/>
-          <a:stretch/>
+          <a:stretch>
+            <a:fillRect/>
+          </a:stretch>
         </p:blipFill>
         <p:spPr>
           <a:xfrm>
-            <a:off x="9393174" y="4087368"/>
-            <a:ext cx="1927098" cy="1156259"/>
+            <a:off x="5332781" y="3392424"/>
+            <a:ext cx="1523390" cy="914034"/>
           </a:xfrm>
           <a:prstGeom prst="rect">
             <a:avLst/>
@@ -9178,8 +9154,8 @@
         </p:nvSpPr>
         <p:spPr>
           <a:xfrm>
-            <a:off x="9027414" y="5303520"/>
-            <a:ext cx="2658618" cy="274320"/>
+            <a:off x="5040173" y="4361688"/>
+            <a:ext cx="2108606" cy="256032"/>
           </a:xfrm>
           <a:prstGeom prst="rect">
             <a:avLst/>
@@ -9195,7 +9171,7 @@
               <a:buNone/>
             </a:pPr>
             <a:r>
-              <a:rPr lang="en-US" sz="950" b="1" dirty="0">
+              <a:rPr lang="en-US" sz="800" b="1" dirty="0">
                 <a:solidFill>
                   <a:srgbClr val="10232E"/>
                 </a:solidFill>
@@ -9203,15 +9179,645 @@
                 <a:ea typeface="Segoe UI" pitchFamily="34" charset="-122"/>
                 <a:cs typeface="Segoe UI" pitchFamily="34" charset="-120"/>
               </a:rPr>
+              <a:t>عبير الديار · Fragrance</a:t>
+            </a:r>
+            <a:endParaRPr lang="en-US" sz="800" dirty="0"/>
+          </a:p>
+        </p:txBody>
+      </p:sp>
+      <p:sp>
+        <p:nvSpPr>
+          <p:cNvPr id="31" name="Shape 21"/>
+          <p:cNvSpPr/>
+          <p:nvPr/>
+        </p:nvSpPr>
+        <p:spPr>
+          <a:xfrm>
+            <a:off x="7304227" y="3282696"/>
+            <a:ext cx="2108606" cy="1389888"/>
+          </a:xfrm>
+          <a:prstGeom prst="roundRect">
+            <a:avLst>
+              <a:gd name="adj" fmla="val 4605"/>
+            </a:avLst>
+          </a:prstGeom>
+          <a:solidFill>
+            <a:srgbClr val="FFFFFF"/>
+          </a:solidFill>
+          <a:ln w="12700">
+            <a:solidFill>
+              <a:srgbClr val="DCE9E6"/>
+            </a:solidFill>
+            <a:prstDash val="solid"/>
+          </a:ln>
+        </p:spPr>
+      </p:sp>
+      <p:pic>
+        <p:nvPicPr>
+          <p:cNvPr id="32" name="Image 8" descr="public/logos/masaken.png">    </p:cNvPr>
+          <p:cNvPicPr>
+            <a:picLocks noChangeAspect="1"/>
+          </p:cNvPicPr>
+          <p:nvPr/>
+        </p:nvPicPr>
+        <p:blipFill>
+          <a:blip r:embed="rId9"/>
+          <a:stretch>
+            <a:fillRect/>
+          </a:stretch>
+        </p:blipFill>
+        <p:spPr>
+          <a:xfrm>
+            <a:off x="7596835" y="3392424"/>
+            <a:ext cx="1523390" cy="914034"/>
+          </a:xfrm>
+          <a:prstGeom prst="rect">
+            <a:avLst/>
+          </a:prstGeom>
+        </p:spPr>
+      </p:pic>
+      <p:sp>
+        <p:nvSpPr>
+          <p:cNvPr id="33" name="Text 22"/>
+          <p:cNvSpPr/>
+          <p:nvPr/>
+        </p:nvSpPr>
+        <p:spPr>
+          <a:xfrm>
+            <a:off x="7304227" y="4361688"/>
+            <a:ext cx="2108606" cy="256032"/>
+          </a:xfrm>
+          <a:prstGeom prst="rect">
+            <a:avLst/>
+          </a:prstGeom>
+          <a:noFill/>
+          <a:ln/>
+        </p:spPr>
+        <p:txBody>
+          <a:bodyPr wrap="square" rtlCol="0" anchor="ctr"/>
+          <a:lstStyle/>
+          <a:p>
+            <a:pPr algn="ctr" indent="0" marL="0">
+              <a:buNone/>
+            </a:pPr>
+            <a:r>
+              <a:rPr lang="en-US" sz="800" b="1" dirty="0">
+                <a:solidFill>
+                  <a:srgbClr val="10232E"/>
+                </a:solidFill>
+                <a:latin typeface="Segoe UI" pitchFamily="34" charset="0"/>
+                <a:ea typeface="Segoe UI" pitchFamily="34" charset="-122"/>
+                <a:cs typeface="Segoe UI" pitchFamily="34" charset="-120"/>
+              </a:rPr>
               <a:t>مساكن · Real Estate</a:t>
             </a:r>
-            <a:endParaRPr lang="en-US" sz="950" dirty="0"/>
-          </a:p>
-        </p:txBody>
-      </p:sp>
-      <p:sp>
-        <p:nvSpPr>
-          <p:cNvPr id="31" name="Text 21"/>
+            <a:endParaRPr lang="en-US" sz="800" dirty="0"/>
+          </a:p>
+        </p:txBody>
+      </p:sp>
+      <p:sp>
+        <p:nvSpPr>
+          <p:cNvPr id="34" name="Shape 23"/>
+          <p:cNvSpPr/>
+          <p:nvPr/>
+        </p:nvSpPr>
+        <p:spPr>
+          <a:xfrm>
+            <a:off x="9568282" y="3282696"/>
+            <a:ext cx="2108606" cy="1389888"/>
+          </a:xfrm>
+          <a:prstGeom prst="roundRect">
+            <a:avLst>
+              <a:gd name="adj" fmla="val 4605"/>
+            </a:avLst>
+          </a:prstGeom>
+          <a:solidFill>
+            <a:srgbClr val="FFFFFF"/>
+          </a:solidFill>
+          <a:ln w="12700">
+            <a:solidFill>
+              <a:srgbClr val="DCE9E6"/>
+            </a:solidFill>
+            <a:prstDash val="solid"/>
+          </a:ln>
+        </p:spPr>
+      </p:sp>
+      <p:pic>
+        <p:nvPicPr>
+          <p:cNvPr id="35" name="Image 9" descr="public/logos/fikra.png">    </p:cNvPr>
+          <p:cNvPicPr>
+            <a:picLocks noChangeAspect="1"/>
+          </p:cNvPicPr>
+          <p:nvPr/>
+        </p:nvPicPr>
+        <p:blipFill>
+          <a:blip r:embed="rId10"/>
+          <a:stretch>
+            <a:fillRect/>
+          </a:stretch>
+        </p:blipFill>
+        <p:spPr>
+          <a:xfrm>
+            <a:off x="9860890" y="3392424"/>
+            <a:ext cx="1523390" cy="914034"/>
+          </a:xfrm>
+          <a:prstGeom prst="rect">
+            <a:avLst/>
+          </a:prstGeom>
+        </p:spPr>
+      </p:pic>
+      <p:sp>
+        <p:nvSpPr>
+          <p:cNvPr id="36" name="Text 24"/>
+          <p:cNvSpPr/>
+          <p:nvPr/>
+        </p:nvSpPr>
+        <p:spPr>
+          <a:xfrm>
+            <a:off x="9568282" y="4361688"/>
+            <a:ext cx="2108606" cy="256032"/>
+          </a:xfrm>
+          <a:prstGeom prst="rect">
+            <a:avLst/>
+          </a:prstGeom>
+          <a:noFill/>
+          <a:ln/>
+        </p:spPr>
+        <p:txBody>
+          <a:bodyPr wrap="square" rtlCol="0" anchor="ctr"/>
+          <a:lstStyle/>
+          <a:p>
+            <a:pPr algn="ctr" indent="0" marL="0">
+              <a:buNone/>
+            </a:pPr>
+            <a:r>
+              <a:rPr lang="en-US" sz="800" b="1" dirty="0">
+                <a:solidFill>
+                  <a:srgbClr val="10232E"/>
+                </a:solidFill>
+                <a:latin typeface="Segoe UI" pitchFamily="34" charset="0"/>
+                <a:ea typeface="Segoe UI" pitchFamily="34" charset="-122"/>
+                <a:cs typeface="Segoe UI" pitchFamily="34" charset="-120"/>
+              </a:rPr>
+              <a:t>فكرة · Creative Studio</a:t>
+            </a:r>
+            <a:endParaRPr lang="en-US" sz="800" dirty="0"/>
+          </a:p>
+        </p:txBody>
+      </p:sp>
+      <p:sp>
+        <p:nvSpPr>
+          <p:cNvPr id="37" name="Shape 25"/>
+          <p:cNvSpPr/>
+          <p:nvPr/>
+        </p:nvSpPr>
+        <p:spPr>
+          <a:xfrm>
+            <a:off x="512064" y="4818888"/>
+            <a:ext cx="2108606" cy="1389888"/>
+          </a:xfrm>
+          <a:prstGeom prst="roundRect">
+            <a:avLst>
+              <a:gd name="adj" fmla="val 4605"/>
+            </a:avLst>
+          </a:prstGeom>
+          <a:solidFill>
+            <a:srgbClr val="FFFFFF"/>
+          </a:solidFill>
+          <a:ln w="12700">
+            <a:solidFill>
+              <a:srgbClr val="DCE9E6"/>
+            </a:solidFill>
+            <a:prstDash val="solid"/>
+          </a:ln>
+        </p:spPr>
+      </p:sp>
+      <p:pic>
+        <p:nvPicPr>
+          <p:cNvPr id="38" name="Image 10" descr="public/logos/basma.png">    </p:cNvPr>
+          <p:cNvPicPr>
+            <a:picLocks noChangeAspect="1"/>
+          </p:cNvPicPr>
+          <p:nvPr/>
+        </p:nvPicPr>
+        <p:blipFill>
+          <a:blip r:embed="rId11"/>
+          <a:stretch>
+            <a:fillRect/>
+          </a:stretch>
+        </p:blipFill>
+        <p:spPr>
+          <a:xfrm>
+            <a:off x="804672" y="4928616"/>
+            <a:ext cx="1523390" cy="914034"/>
+          </a:xfrm>
+          <a:prstGeom prst="rect">
+            <a:avLst/>
+          </a:prstGeom>
+        </p:spPr>
+      </p:pic>
+      <p:sp>
+        <p:nvSpPr>
+          <p:cNvPr id="39" name="Text 26"/>
+          <p:cNvSpPr/>
+          <p:nvPr/>
+        </p:nvSpPr>
+        <p:spPr>
+          <a:xfrm>
+            <a:off x="512064" y="5897880"/>
+            <a:ext cx="2108606" cy="256032"/>
+          </a:xfrm>
+          <a:prstGeom prst="rect">
+            <a:avLst/>
+          </a:prstGeom>
+          <a:noFill/>
+          <a:ln/>
+        </p:spPr>
+        <p:txBody>
+          <a:bodyPr wrap="square" rtlCol="0" anchor="ctr"/>
+          <a:lstStyle/>
+          <a:p>
+            <a:pPr algn="ctr" indent="0" marL="0">
+              <a:buNone/>
+            </a:pPr>
+            <a:r>
+              <a:rPr lang="en-US" sz="800" b="1" dirty="0">
+                <a:solidFill>
+                  <a:srgbClr val="10232E"/>
+                </a:solidFill>
+                <a:latin typeface="Segoe UI" pitchFamily="34" charset="0"/>
+                <a:ea typeface="Segoe UI" pitchFamily="34" charset="-122"/>
+                <a:cs typeface="Segoe UI" pitchFamily="34" charset="-120"/>
+              </a:rPr>
+              <a:t>بصمة · Software House</a:t>
+            </a:r>
+            <a:endParaRPr lang="en-US" sz="800" dirty="0"/>
+          </a:p>
+        </p:txBody>
+      </p:sp>
+      <p:sp>
+        <p:nvSpPr>
+          <p:cNvPr id="40" name="Shape 27"/>
+          <p:cNvSpPr/>
+          <p:nvPr/>
+        </p:nvSpPr>
+        <p:spPr>
+          <a:xfrm>
+            <a:off x="2776118" y="4818888"/>
+            <a:ext cx="2108606" cy="1389888"/>
+          </a:xfrm>
+          <a:prstGeom prst="roundRect">
+            <a:avLst>
+              <a:gd name="adj" fmla="val 4605"/>
+            </a:avLst>
+          </a:prstGeom>
+          <a:solidFill>
+            <a:srgbClr val="FFFFFF"/>
+          </a:solidFill>
+          <a:ln w="12700">
+            <a:solidFill>
+              <a:srgbClr val="DCE9E6"/>
+            </a:solidFill>
+            <a:prstDash val="solid"/>
+          </a:ln>
+        </p:spPr>
+      </p:sp>
+      <p:pic>
+        <p:nvPicPr>
+          <p:cNvPr id="41" name="Image 11" descr="public/logos/nashra.png">    </p:cNvPr>
+          <p:cNvPicPr>
+            <a:picLocks noChangeAspect="1"/>
+          </p:cNvPicPr>
+          <p:nvPr/>
+        </p:nvPicPr>
+        <p:blipFill>
+          <a:blip r:embed="rId12"/>
+          <a:stretch>
+            <a:fillRect/>
+          </a:stretch>
+        </p:blipFill>
+        <p:spPr>
+          <a:xfrm>
+            <a:off x="3068726" y="4928616"/>
+            <a:ext cx="1523390" cy="914034"/>
+          </a:xfrm>
+          <a:prstGeom prst="rect">
+            <a:avLst/>
+          </a:prstGeom>
+        </p:spPr>
+      </p:pic>
+      <p:sp>
+        <p:nvSpPr>
+          <p:cNvPr id="42" name="Text 28"/>
+          <p:cNvSpPr/>
+          <p:nvPr/>
+        </p:nvSpPr>
+        <p:spPr>
+          <a:xfrm>
+            <a:off x="2776118" y="5897880"/>
+            <a:ext cx="2108606" cy="256032"/>
+          </a:xfrm>
+          <a:prstGeom prst="rect">
+            <a:avLst/>
+          </a:prstGeom>
+          <a:noFill/>
+          <a:ln/>
+        </p:spPr>
+        <p:txBody>
+          <a:bodyPr wrap="square" rtlCol="0" anchor="ctr"/>
+          <a:lstStyle/>
+          <a:p>
+            <a:pPr algn="ctr" indent="0" marL="0">
+              <a:buNone/>
+            </a:pPr>
+            <a:r>
+              <a:rPr lang="en-US" sz="800" b="1" dirty="0">
+                <a:solidFill>
+                  <a:srgbClr val="10232E"/>
+                </a:solidFill>
+                <a:latin typeface="Segoe UI" pitchFamily="34" charset="0"/>
+                <a:ea typeface="Segoe UI" pitchFamily="34" charset="-122"/>
+                <a:cs typeface="Segoe UI" pitchFamily="34" charset="-120"/>
+              </a:rPr>
+              <a:t>نشرة · News Platform</a:t>
+            </a:r>
+            <a:endParaRPr lang="en-US" sz="800" dirty="0"/>
+          </a:p>
+        </p:txBody>
+      </p:sp>
+      <p:sp>
+        <p:nvSpPr>
+          <p:cNvPr id="43" name="Shape 29"/>
+          <p:cNvSpPr/>
+          <p:nvPr/>
+        </p:nvSpPr>
+        <p:spPr>
+          <a:xfrm>
+            <a:off x="5040173" y="4818888"/>
+            <a:ext cx="2108606" cy="1389888"/>
+          </a:xfrm>
+          <a:prstGeom prst="roundRect">
+            <a:avLst>
+              <a:gd name="adj" fmla="val 4605"/>
+            </a:avLst>
+          </a:prstGeom>
+          <a:solidFill>
+            <a:srgbClr val="FFFFFF"/>
+          </a:solidFill>
+          <a:ln w="12700">
+            <a:solidFill>
+              <a:srgbClr val="DCE9E6"/>
+            </a:solidFill>
+            <a:prstDash val="solid"/>
+          </a:ln>
+        </p:spPr>
+      </p:sp>
+      <p:pic>
+        <p:nvPicPr>
+          <p:cNvPr id="44" name="Image 12" descr="public/logos/wijdan-yoga.png">    </p:cNvPr>
+          <p:cNvPicPr>
+            <a:picLocks noChangeAspect="1"/>
+          </p:cNvPicPr>
+          <p:nvPr/>
+        </p:nvPicPr>
+        <p:blipFill>
+          <a:blip r:embed="rId13"/>
+          <a:stretch>
+            <a:fillRect/>
+          </a:stretch>
+        </p:blipFill>
+        <p:spPr>
+          <a:xfrm>
+            <a:off x="5332781" y="4928616"/>
+            <a:ext cx="1523390" cy="914034"/>
+          </a:xfrm>
+          <a:prstGeom prst="rect">
+            <a:avLst/>
+          </a:prstGeom>
+        </p:spPr>
+      </p:pic>
+      <p:sp>
+        <p:nvSpPr>
+          <p:cNvPr id="45" name="Text 30"/>
+          <p:cNvSpPr/>
+          <p:nvPr/>
+        </p:nvSpPr>
+        <p:spPr>
+          <a:xfrm>
+            <a:off x="5040173" y="5897880"/>
+            <a:ext cx="2108606" cy="256032"/>
+          </a:xfrm>
+          <a:prstGeom prst="rect">
+            <a:avLst/>
+          </a:prstGeom>
+          <a:noFill/>
+          <a:ln/>
+        </p:spPr>
+        <p:txBody>
+          <a:bodyPr wrap="square" rtlCol="0" anchor="ctr"/>
+          <a:lstStyle/>
+          <a:p>
+            <a:pPr algn="ctr" indent="0" marL="0">
+              <a:buNone/>
+            </a:pPr>
+            <a:r>
+              <a:rPr lang="en-US" sz="800" b="1" dirty="0">
+                <a:solidFill>
+                  <a:srgbClr val="10232E"/>
+                </a:solidFill>
+                <a:latin typeface="Segoe UI" pitchFamily="34" charset="0"/>
+                <a:ea typeface="Segoe UI" pitchFamily="34" charset="-122"/>
+                <a:cs typeface="Segoe UI" pitchFamily="34" charset="-120"/>
+              </a:rPr>
+              <a:t>وجدان · Yoga Space</a:t>
+            </a:r>
+            <a:endParaRPr lang="en-US" sz="800" dirty="0"/>
+          </a:p>
+        </p:txBody>
+      </p:sp>
+      <p:sp>
+        <p:nvSpPr>
+          <p:cNvPr id="46" name="Shape 31"/>
+          <p:cNvSpPr/>
+          <p:nvPr/>
+        </p:nvSpPr>
+        <p:spPr>
+          <a:xfrm>
+            <a:off x="7304227" y="4818888"/>
+            <a:ext cx="2108606" cy="1389888"/>
+          </a:xfrm>
+          <a:prstGeom prst="roundRect">
+            <a:avLst>
+              <a:gd name="adj" fmla="val 4605"/>
+            </a:avLst>
+          </a:prstGeom>
+          <a:solidFill>
+            <a:srgbClr val="FFFFFF"/>
+          </a:solidFill>
+          <a:ln w="12700">
+            <a:solidFill>
+              <a:srgbClr val="DCE9E6"/>
+            </a:solidFill>
+            <a:prstDash val="solid"/>
+          </a:ln>
+        </p:spPr>
+      </p:sp>
+      <p:pic>
+        <p:nvPicPr>
+          <p:cNvPr id="47" name="Image 13" descr="public/logos/vet-clinic.png">    </p:cNvPr>
+          <p:cNvPicPr>
+            <a:picLocks noChangeAspect="1"/>
+          </p:cNvPicPr>
+          <p:nvPr/>
+        </p:nvPicPr>
+        <p:blipFill>
+          <a:blip r:embed="rId14"/>
+          <a:stretch>
+            <a:fillRect/>
+          </a:stretch>
+        </p:blipFill>
+        <p:spPr>
+          <a:xfrm>
+            <a:off x="7596835" y="4928616"/>
+            <a:ext cx="1523390" cy="914034"/>
+          </a:xfrm>
+          <a:prstGeom prst="rect">
+            <a:avLst/>
+          </a:prstGeom>
+        </p:spPr>
+      </p:pic>
+      <p:sp>
+        <p:nvSpPr>
+          <p:cNvPr id="48" name="Text 32"/>
+          <p:cNvSpPr/>
+          <p:nvPr/>
+        </p:nvSpPr>
+        <p:spPr>
+          <a:xfrm>
+            <a:off x="7304227" y="5897880"/>
+            <a:ext cx="2108606" cy="256032"/>
+          </a:xfrm>
+          <a:prstGeom prst="rect">
+            <a:avLst/>
+          </a:prstGeom>
+          <a:noFill/>
+          <a:ln/>
+        </p:spPr>
+        <p:txBody>
+          <a:bodyPr wrap="square" rtlCol="0" anchor="ctr"/>
+          <a:lstStyle/>
+          <a:p>
+            <a:pPr algn="ctr" indent="0" marL="0">
+              <a:buNone/>
+            </a:pPr>
+            <a:r>
+              <a:rPr lang="en-US" sz="800" b="1" dirty="0">
+                <a:solidFill>
+                  <a:srgbClr val="10232E"/>
+                </a:solidFill>
+                <a:latin typeface="Segoe UI" pitchFamily="34" charset="0"/>
+                <a:ea typeface="Segoe UI" pitchFamily="34" charset="-122"/>
+                <a:cs typeface="Segoe UI" pitchFamily="34" charset="-120"/>
+              </a:rPr>
+              <a:t>Vet Clinic · Pet Care</a:t>
+            </a:r>
+            <a:endParaRPr lang="en-US" sz="800" dirty="0"/>
+          </a:p>
+        </p:txBody>
+      </p:sp>
+      <p:sp>
+        <p:nvSpPr>
+          <p:cNvPr id="49" name="Shape 33"/>
+          <p:cNvSpPr/>
+          <p:nvPr/>
+        </p:nvSpPr>
+        <p:spPr>
+          <a:xfrm>
+            <a:off x="9568282" y="4818888"/>
+            <a:ext cx="2108606" cy="1389888"/>
+          </a:xfrm>
+          <a:prstGeom prst="roundRect">
+            <a:avLst>
+              <a:gd name="adj" fmla="val 4605"/>
+            </a:avLst>
+          </a:prstGeom>
+          <a:solidFill>
+            <a:srgbClr val="FFFFFF"/>
+          </a:solidFill>
+          <a:ln w="12700">
+            <a:solidFill>
+              <a:srgbClr val="DCE9E6"/>
+            </a:solidFill>
+            <a:prstDash val="solid"/>
+          </a:ln>
+        </p:spPr>
+      </p:sp>
+      <p:pic>
+        <p:nvPicPr>
+          <p:cNvPr id="50" name="Image 14" descr="public/logos/respawn-lab.png">    </p:cNvPr>
+          <p:cNvPicPr>
+            <a:picLocks noChangeAspect="1"/>
+          </p:cNvPicPr>
+          <p:nvPr/>
+        </p:nvPicPr>
+        <p:blipFill>
+          <a:blip r:embed="rId15"/>
+          <a:stretch>
+            <a:fillRect/>
+          </a:stretch>
+        </p:blipFill>
+        <p:spPr>
+          <a:xfrm>
+            <a:off x="9860890" y="4928616"/>
+            <a:ext cx="1523390" cy="914034"/>
+          </a:xfrm>
+          <a:prstGeom prst="rect">
+            <a:avLst/>
+          </a:prstGeom>
+        </p:spPr>
+      </p:pic>
+      <p:sp>
+        <p:nvSpPr>
+          <p:cNvPr id="51" name="Text 34"/>
+          <p:cNvSpPr/>
+          <p:nvPr/>
+        </p:nvSpPr>
+        <p:spPr>
+          <a:xfrm>
+            <a:off x="9568282" y="5897880"/>
+            <a:ext cx="2108606" cy="256032"/>
+          </a:xfrm>
+          <a:prstGeom prst="rect">
+            <a:avLst/>
+          </a:prstGeom>
+          <a:noFill/>
+          <a:ln/>
+        </p:spPr>
+        <p:txBody>
+          <a:bodyPr wrap="square" rtlCol="0" anchor="ctr"/>
+          <a:lstStyle/>
+          <a:p>
+            <a:pPr algn="ctr" indent="0" marL="0">
+              <a:buNone/>
+            </a:pPr>
+            <a:r>
+              <a:rPr lang="en-US" sz="800" b="1" dirty="0">
+                <a:solidFill>
+                  <a:srgbClr val="10232E"/>
+                </a:solidFill>
+                <a:latin typeface="Segoe UI" pitchFamily="34" charset="0"/>
+                <a:ea typeface="Segoe UI" pitchFamily="34" charset="-122"/>
+                <a:cs typeface="Segoe UI" pitchFamily="34" charset="-120"/>
+              </a:rPr>
+              <a:t>Respawn Lab · Gaming</a:t>
+            </a:r>
+            <a:endParaRPr lang="en-US" sz="800" dirty="0"/>
+          </a:p>
+        </p:txBody>
+      </p:sp>
+      <p:sp>
+        <p:nvSpPr>
+          <p:cNvPr id="52" name="Text 35"/>
           <p:cNvSpPr/>
           <p:nvPr/>
         </p:nvSpPr>
@@ -9264,7 +9870,7 @@
       </p:sp>
       <p:sp>
         <p:nvSpPr>
-          <p:cNvPr id="32" name="Text 22"/>
+          <p:cNvPr id="53" name="Text 36"/>
           <p:cNvSpPr/>
           <p:nvPr/>
         </p:nvSpPr>
@@ -11401,38 +12007,32 @@
           </a:ln>
         </p:spPr>
       </p:sp>
-      <p:pic>
-        <p:nvPicPr>
-          <p:cNvPr id="41" name="Image 0" descr="public/ceo.jpg">    </p:cNvPr>
-          <p:cNvPicPr>
-            <a:picLocks noChangeAspect="1"/>
-          </p:cNvPicPr>
-          <p:nvPr/>
-        </p:nvPicPr>
-        <p:blipFill>
-          <a:blip r:embed="rId1"/>
-          <a:srcRect l="0" r="0" t="0" b="0"/>
-          <a:stretch/>
-        </p:blipFill>
-        <p:spPr>
-          <a:xfrm>
-            <a:off x="5605272" y="3090672"/>
-            <a:ext cx="1042416" cy="1042416"/>
-          </a:xfrm>
-          <a:prstGeom prst="ellipse">
-            <a:avLst/>
-          </a:prstGeom>
-        </p:spPr>
-      </p:pic>
-      <p:sp>
-        <p:nvSpPr>
-          <p:cNvPr id="42" name="Text 39"/>
-          <p:cNvSpPr/>
-          <p:nvPr/>
-        </p:nvSpPr>
-        <p:spPr>
-          <a:xfrm>
-            <a:off x="6812280" y="3154680"/>
+      <p:sp>
+        <p:nvSpPr>
+          <p:cNvPr id="41" name="Shape 39"/>
+          <p:cNvSpPr/>
+          <p:nvPr/>
+        </p:nvSpPr>
+        <p:spPr>
+          <a:xfrm>
+            <a:off x="5641848" y="3127248"/>
+            <a:ext cx="50292" cy="969264"/>
+          </a:xfrm>
+          <a:prstGeom prst="rect">
+            <a:avLst/>
+          </a:prstGeom>
+          <a:ln/>
+        </p:spPr>
+      </p:sp>
+      <p:sp>
+        <p:nvSpPr>
+          <p:cNvPr id="42" name="Text 40"/>
+          <p:cNvSpPr/>
+          <p:nvPr/>
+        </p:nvSpPr>
+        <p:spPr>
+          <a:xfrm>
+            <a:off x="5852160" y="3127248"/>
             <a:ext cx="4114800" cy="320040"/>
           </a:xfrm>
           <a:prstGeom prst="rect">
@@ -11465,13 +12065,13 @@
       </p:sp>
       <p:sp>
         <p:nvSpPr>
-          <p:cNvPr id="43" name="Text 40"/>
-          <p:cNvSpPr/>
-          <p:nvPr/>
-        </p:nvSpPr>
-        <p:spPr>
-          <a:xfrm>
-            <a:off x="6812280" y="3465576"/>
+          <p:cNvPr id="43" name="Text 41"/>
+          <p:cNvSpPr/>
+          <p:nvPr/>
+        </p:nvSpPr>
+        <p:spPr>
+          <a:xfrm>
+            <a:off x="5852160" y="3438144"/>
             <a:ext cx="4114800" cy="274320"/>
           </a:xfrm>
           <a:prstGeom prst="rect">
@@ -11504,14 +12104,14 @@
       </p:sp>
       <p:sp>
         <p:nvSpPr>
-          <p:cNvPr id="44" name="Text 41"/>
-          <p:cNvSpPr/>
-          <p:nvPr/>
-        </p:nvSpPr>
-        <p:spPr>
-          <a:xfrm>
-            <a:off x="6812280" y="3739896"/>
-            <a:ext cx="4645152" cy="502920"/>
+          <p:cNvPr id="44" name="Text 42"/>
+          <p:cNvSpPr/>
+          <p:nvPr/>
+        </p:nvSpPr>
+        <p:spPr>
+          <a:xfrm>
+            <a:off x="5852160" y="3712464"/>
+            <a:ext cx="5559552" cy="502920"/>
           </a:xfrm>
           <a:prstGeom prst="rect">
             <a:avLst/>
@@ -11546,7 +12146,7 @@
       </p:sp>
       <p:sp>
         <p:nvSpPr>
-          <p:cNvPr id="45" name="Text 42"/>
+          <p:cNvPr id="45" name="Text 43"/>
           <p:cNvSpPr/>
           <p:nvPr/>
         </p:nvSpPr>
@@ -11585,7 +12185,7 @@
       </p:sp>
       <p:sp>
         <p:nvSpPr>
-          <p:cNvPr id="46" name="Shape 43"/>
+          <p:cNvPr id="46" name="Shape 44"/>
           <p:cNvSpPr/>
           <p:nvPr/>
         </p:nvSpPr>
@@ -11602,7 +12202,7 @@
       </p:sp>
       <p:sp>
         <p:nvSpPr>
-          <p:cNvPr id="47" name="Shape 44"/>
+          <p:cNvPr id="47" name="Shape 45"/>
           <p:cNvSpPr/>
           <p:nvPr/>
         </p:nvSpPr>
@@ -11629,7 +12229,7 @@
       </p:sp>
       <p:sp>
         <p:nvSpPr>
-          <p:cNvPr id="48" name="Text 45"/>
+          <p:cNvPr id="48" name="Text 46"/>
           <p:cNvSpPr/>
           <p:nvPr/>
         </p:nvSpPr>
@@ -11668,7 +12268,7 @@
       </p:sp>
       <p:sp>
         <p:nvSpPr>
-          <p:cNvPr id="49" name="Shape 46"/>
+          <p:cNvPr id="49" name="Shape 47"/>
           <p:cNvSpPr/>
           <p:nvPr/>
         </p:nvSpPr>
@@ -11695,7 +12295,7 @@
       </p:sp>
       <p:sp>
         <p:nvSpPr>
-          <p:cNvPr id="50" name="Text 47"/>
+          <p:cNvPr id="50" name="Text 48"/>
           <p:cNvSpPr/>
           <p:nvPr/>
         </p:nvSpPr>
@@ -11734,7 +12334,7 @@
       </p:sp>
       <p:sp>
         <p:nvSpPr>
-          <p:cNvPr id="51" name="Shape 48"/>
+          <p:cNvPr id="51" name="Shape 49"/>
           <p:cNvSpPr/>
           <p:nvPr/>
         </p:nvSpPr>
@@ -11761,7 +12361,7 @@
       </p:sp>
       <p:sp>
         <p:nvSpPr>
-          <p:cNvPr id="52" name="Text 49"/>
+          <p:cNvPr id="52" name="Text 50"/>
           <p:cNvSpPr/>
           <p:nvPr/>
         </p:nvSpPr>
@@ -11800,7 +12400,7 @@
       </p:sp>
       <p:sp>
         <p:nvSpPr>
-          <p:cNvPr id="53" name="Shape 50"/>
+          <p:cNvPr id="53" name="Shape 51"/>
           <p:cNvSpPr/>
           <p:nvPr/>
         </p:nvSpPr>
@@ -11827,7 +12427,7 @@
       </p:sp>
       <p:sp>
         <p:nvSpPr>
-          <p:cNvPr id="54" name="Text 51"/>
+          <p:cNvPr id="54" name="Text 52"/>
           <p:cNvSpPr/>
           <p:nvPr/>
         </p:nvSpPr>
@@ -11866,7 +12466,7 @@
       </p:sp>
       <p:sp>
         <p:nvSpPr>
-          <p:cNvPr id="55" name="Shape 52"/>
+          <p:cNvPr id="55" name="Shape 53"/>
           <p:cNvSpPr/>
           <p:nvPr/>
         </p:nvSpPr>
@@ -11893,7 +12493,7 @@
       </p:sp>
       <p:sp>
         <p:nvSpPr>
-          <p:cNvPr id="56" name="Text 53"/>
+          <p:cNvPr id="56" name="Text 54"/>
           <p:cNvSpPr/>
           <p:nvPr/>
         </p:nvSpPr>
@@ -11932,7 +12532,7 @@
       </p:sp>
       <p:sp>
         <p:nvSpPr>
-          <p:cNvPr id="57" name="Shape 54"/>
+          <p:cNvPr id="57" name="Shape 55"/>
           <p:cNvSpPr/>
           <p:nvPr/>
         </p:nvSpPr>
@@ -11959,7 +12559,7 @@
       </p:sp>
       <p:sp>
         <p:nvSpPr>
-          <p:cNvPr id="58" name="Text 55"/>
+          <p:cNvPr id="58" name="Text 56"/>
           <p:cNvSpPr/>
           <p:nvPr/>
         </p:nvSpPr>
@@ -11998,7 +12598,7 @@
       </p:sp>
       <p:sp>
         <p:nvSpPr>
-          <p:cNvPr id="59" name="Text 56"/>
+          <p:cNvPr id="59" name="Text 57"/>
           <p:cNvSpPr/>
           <p:nvPr/>
         </p:nvSpPr>
@@ -12051,7 +12651,7 @@
       </p:sp>
       <p:sp>
         <p:nvSpPr>
-          <p:cNvPr id="60" name="Text 57"/>
+          <p:cNvPr id="60" name="Text 58"/>
           <p:cNvSpPr/>
           <p:nvPr/>
         </p:nvSpPr>
@@ -19059,7 +19659,7 @@
       </p:sp>
       <p:pic>
         <p:nvPicPr>
-          <p:cNvPr id="7" name="Image 0" descr="public/projects/nexa-pay.jpg">    </p:cNvPr>
+          <p:cNvPr id="7" name="Image 0" descr="public/profile-assets/nexa-pay-tile.jpg">    </p:cNvPr>
           <p:cNvPicPr>
             <a:picLocks noChangeAspect="1"/>
           </p:cNvPicPr>
@@ -19067,13 +19667,14 @@
         </p:nvPicPr>
         <p:blipFill>
           <a:blip r:embed="rId1"/>
-          <a:srcRect l="0" r="0" t="0" b="0"/>
-          <a:stretch/>
+          <a:stretch>
+            <a:fillRect/>
+          </a:stretch>
         </p:blipFill>
         <p:spPr>
           <a:xfrm>
-            <a:off x="548640" y="1691640"/>
-            <a:ext cx="3544824" cy="1417320"/>
+            <a:off x="548640" y="1645920"/>
+            <a:ext cx="3544824" cy="1737318"/>
           </a:xfrm>
           <a:prstGeom prst="rect">
             <a:avLst/>
@@ -19088,24 +19689,24 @@
         </p:nvSpPr>
         <p:spPr>
           <a:xfrm>
-            <a:off x="548640" y="3127248"/>
-            <a:ext cx="3544824" cy="274320"/>
-          </a:xfrm>
-          <a:prstGeom prst="rect">
-            <a:avLst/>
-          </a:prstGeom>
-          <a:noFill/>
-          <a:ln/>
-        </p:spPr>
-        <p:txBody>
-          <a:bodyPr wrap="square" rtlCol="0" anchor="ctr"/>
-          <a:lstStyle/>
-          <a:p>
-            <a:pPr indent="0" marL="0">
-              <a:buNone/>
-            </a:pPr>
-            <a:r>
-              <a:rPr lang="en-US" sz="1250" b="1" dirty="0">
+            <a:off x="548640" y="3410670"/>
+            <a:ext cx="3544824" cy="256032"/>
+          </a:xfrm>
+          <a:prstGeom prst="rect">
+            <a:avLst/>
+          </a:prstGeom>
+          <a:noFill/>
+          <a:ln/>
+        </p:spPr>
+        <p:txBody>
+          <a:bodyPr wrap="square" rtlCol="0" anchor="ctr"/>
+          <a:lstStyle/>
+          <a:p>
+            <a:pPr indent="0" marL="0">
+              <a:buNone/>
+            </a:pPr>
+            <a:r>
+              <a:rPr lang="en-US" sz="1200" b="1" dirty="0">
                 <a:solidFill>
                   <a:srgbClr val="10232E"/>
                 </a:solidFill>
@@ -19115,7 +19716,7 @@
               </a:rPr>
               <a:t>Nexa Pay</a:t>
             </a:r>
-            <a:endParaRPr lang="en-US" sz="1250" dirty="0"/>
+            <a:endParaRPr lang="en-US" sz="1200" dirty="0"/>
           </a:p>
         </p:txBody>
       </p:sp>
@@ -19127,8 +19728,8 @@
         </p:nvSpPr>
         <p:spPr>
           <a:xfrm>
-            <a:off x="548640" y="3383280"/>
-            <a:ext cx="3544824" cy="274320"/>
+            <a:off x="548640" y="3657558"/>
+            <a:ext cx="3544824" cy="256032"/>
           </a:xfrm>
           <a:prstGeom prst="rect">
             <a:avLst/>
@@ -19160,7 +19761,7 @@
       </p:sp>
       <p:pic>
         <p:nvPicPr>
-          <p:cNvPr id="10" name="Image 1" descr="public/projects/cargoflow.jpg">    </p:cNvPr>
+          <p:cNvPr id="10" name="Image 1" descr="public/profile-assets/cargoflow-tile.jpg">    </p:cNvPr>
           <p:cNvPicPr>
             <a:picLocks noChangeAspect="1"/>
           </p:cNvPicPr>
@@ -19168,13 +19769,14 @@
         </p:nvPicPr>
         <p:blipFill>
           <a:blip r:embed="rId2"/>
-          <a:srcRect l="0" r="0" t="0" b="0"/>
-          <a:stretch/>
+          <a:stretch>
+            <a:fillRect/>
+          </a:stretch>
         </p:blipFill>
         <p:spPr>
           <a:xfrm>
-            <a:off x="4322064" y="1691640"/>
-            <a:ext cx="3544824" cy="1417320"/>
+            <a:off x="4322064" y="1645920"/>
+            <a:ext cx="3544824" cy="1737318"/>
           </a:xfrm>
           <a:prstGeom prst="rect">
             <a:avLst/>
@@ -19189,24 +19791,24 @@
         </p:nvSpPr>
         <p:spPr>
           <a:xfrm>
-            <a:off x="4322064" y="3127248"/>
-            <a:ext cx="3544824" cy="274320"/>
-          </a:xfrm>
-          <a:prstGeom prst="rect">
-            <a:avLst/>
-          </a:prstGeom>
-          <a:noFill/>
-          <a:ln/>
-        </p:spPr>
-        <p:txBody>
-          <a:bodyPr wrap="square" rtlCol="0" anchor="ctr"/>
-          <a:lstStyle/>
-          <a:p>
-            <a:pPr indent="0" marL="0">
-              <a:buNone/>
-            </a:pPr>
-            <a:r>
-              <a:rPr lang="en-US" sz="1250" b="1" dirty="0">
+            <a:off x="4322064" y="3410670"/>
+            <a:ext cx="3544824" cy="256032"/>
+          </a:xfrm>
+          <a:prstGeom prst="rect">
+            <a:avLst/>
+          </a:prstGeom>
+          <a:noFill/>
+          <a:ln/>
+        </p:spPr>
+        <p:txBody>
+          <a:bodyPr wrap="square" rtlCol="0" anchor="ctr"/>
+          <a:lstStyle/>
+          <a:p>
+            <a:pPr indent="0" marL="0">
+              <a:buNone/>
+            </a:pPr>
+            <a:r>
+              <a:rPr lang="en-US" sz="1200" b="1" dirty="0">
                 <a:solidFill>
                   <a:srgbClr val="10232E"/>
                 </a:solidFill>
@@ -19216,7 +19818,7 @@
               </a:rPr>
               <a:t>CargoFlow</a:t>
             </a:r>
-            <a:endParaRPr lang="en-US" sz="1250" dirty="0"/>
+            <a:endParaRPr lang="en-US" sz="1200" dirty="0"/>
           </a:p>
         </p:txBody>
       </p:sp>
@@ -19228,8 +19830,8 @@
         </p:nvSpPr>
         <p:spPr>
           <a:xfrm>
-            <a:off x="4322064" y="3383280"/>
-            <a:ext cx="3544824" cy="274320"/>
+            <a:off x="4322064" y="3657558"/>
+            <a:ext cx="3544824" cy="256032"/>
           </a:xfrm>
           <a:prstGeom prst="rect">
             <a:avLst/>
@@ -19261,7 +19863,7 @@
       </p:sp>
       <p:pic>
         <p:nvPicPr>
-          <p:cNvPr id="13" name="Image 2" descr="public/projects/lumora.jpg">    </p:cNvPr>
+          <p:cNvPr id="13" name="Image 2" descr="public/profile-assets/lumora-tile.jpg">    </p:cNvPr>
           <p:cNvPicPr>
             <a:picLocks noChangeAspect="1"/>
           </p:cNvPicPr>
@@ -19269,13 +19871,14 @@
         </p:nvPicPr>
         <p:blipFill>
           <a:blip r:embed="rId3"/>
-          <a:srcRect l="0" r="0" t="0" b="0"/>
-          <a:stretch/>
+          <a:stretch>
+            <a:fillRect/>
+          </a:stretch>
         </p:blipFill>
         <p:spPr>
           <a:xfrm>
-            <a:off x="8095488" y="1691640"/>
-            <a:ext cx="3544824" cy="1417320"/>
+            <a:off x="8095488" y="1645920"/>
+            <a:ext cx="3544824" cy="1737318"/>
           </a:xfrm>
           <a:prstGeom prst="rect">
             <a:avLst/>
@@ -19290,24 +19893,24 @@
         </p:nvSpPr>
         <p:spPr>
           <a:xfrm>
-            <a:off x="8095488" y="3127248"/>
-            <a:ext cx="3544824" cy="274320"/>
-          </a:xfrm>
-          <a:prstGeom prst="rect">
-            <a:avLst/>
-          </a:prstGeom>
-          <a:noFill/>
-          <a:ln/>
-        </p:spPr>
-        <p:txBody>
-          <a:bodyPr wrap="square" rtlCol="0" anchor="ctr"/>
-          <a:lstStyle/>
-          <a:p>
-            <a:pPr indent="0" marL="0">
-              <a:buNone/>
-            </a:pPr>
-            <a:r>
-              <a:rPr lang="en-US" sz="1250" b="1" dirty="0">
+            <a:off x="8095488" y="3410670"/>
+            <a:ext cx="3544824" cy="256032"/>
+          </a:xfrm>
+          <a:prstGeom prst="rect">
+            <a:avLst/>
+          </a:prstGeom>
+          <a:noFill/>
+          <a:ln/>
+        </p:spPr>
+        <p:txBody>
+          <a:bodyPr wrap="square" rtlCol="0" anchor="ctr"/>
+          <a:lstStyle/>
+          <a:p>
+            <a:pPr indent="0" marL="0">
+              <a:buNone/>
+            </a:pPr>
+            <a:r>
+              <a:rPr lang="en-US" sz="1200" b="1" dirty="0">
                 <a:solidFill>
                   <a:srgbClr val="10232E"/>
                 </a:solidFill>
@@ -19317,7 +19920,7 @@
               </a:rPr>
               <a:t>Lumora</a:t>
             </a:r>
-            <a:endParaRPr lang="en-US" sz="1250" dirty="0"/>
+            <a:endParaRPr lang="en-US" sz="1200" dirty="0"/>
           </a:p>
         </p:txBody>
       </p:sp>
@@ -19329,8 +19932,8 @@
         </p:nvSpPr>
         <p:spPr>
           <a:xfrm>
-            <a:off x="8095488" y="3383280"/>
-            <a:ext cx="3544824" cy="274320"/>
+            <a:off x="8095488" y="3657558"/>
+            <a:ext cx="3544824" cy="256032"/>
           </a:xfrm>
           <a:prstGeom prst="rect">
             <a:avLst/>
@@ -19362,7 +19965,7 @@
       </p:sp>
       <p:pic>
         <p:nvPicPr>
-          <p:cNvPr id="16" name="Image 3" descr="public/projects/pulse-loop.jpg">    </p:cNvPr>
+          <p:cNvPr id="16" name="Image 3" descr="public/profile-assets/pulse-loop-tile.jpg">    </p:cNvPr>
           <p:cNvPicPr>
             <a:picLocks noChangeAspect="1"/>
           </p:cNvPicPr>
@@ -19370,13 +19973,14 @@
         </p:nvPicPr>
         <p:blipFill>
           <a:blip r:embed="rId4"/>
-          <a:srcRect l="0" r="0" t="0" b="0"/>
-          <a:stretch/>
+          <a:stretch>
+            <a:fillRect/>
+          </a:stretch>
         </p:blipFill>
         <p:spPr>
           <a:xfrm>
-            <a:off x="548640" y="3840480"/>
-            <a:ext cx="3544824" cy="1417320"/>
+            <a:off x="548640" y="4041648"/>
+            <a:ext cx="3544824" cy="1737318"/>
           </a:xfrm>
           <a:prstGeom prst="rect">
             <a:avLst/>
@@ -19391,24 +19995,24 @@
         </p:nvSpPr>
         <p:spPr>
           <a:xfrm>
-            <a:off x="548640" y="5276088"/>
-            <a:ext cx="3544824" cy="274320"/>
-          </a:xfrm>
-          <a:prstGeom prst="rect">
-            <a:avLst/>
-          </a:prstGeom>
-          <a:noFill/>
-          <a:ln/>
-        </p:spPr>
-        <p:txBody>
-          <a:bodyPr wrap="square" rtlCol="0" anchor="ctr"/>
-          <a:lstStyle/>
-          <a:p>
-            <a:pPr indent="0" marL="0">
-              <a:buNone/>
-            </a:pPr>
-            <a:r>
-              <a:rPr lang="en-US" sz="1250" b="1" dirty="0">
+            <a:off x="548640" y="5806398"/>
+            <a:ext cx="3544824" cy="256032"/>
+          </a:xfrm>
+          <a:prstGeom prst="rect">
+            <a:avLst/>
+          </a:prstGeom>
+          <a:noFill/>
+          <a:ln/>
+        </p:spPr>
+        <p:txBody>
+          <a:bodyPr wrap="square" rtlCol="0" anchor="ctr"/>
+          <a:lstStyle/>
+          <a:p>
+            <a:pPr indent="0" marL="0">
+              <a:buNone/>
+            </a:pPr>
+            <a:r>
+              <a:rPr lang="en-US" sz="1200" b="1" dirty="0">
                 <a:solidFill>
                   <a:srgbClr val="10232E"/>
                 </a:solidFill>
@@ -19418,7 +20022,7 @@
               </a:rPr>
               <a:t>Pulse Loop</a:t>
             </a:r>
-            <a:endParaRPr lang="en-US" sz="1250" dirty="0"/>
+            <a:endParaRPr lang="en-US" sz="1200" dirty="0"/>
           </a:p>
         </p:txBody>
       </p:sp>
@@ -19430,8 +20034,8 @@
         </p:nvSpPr>
         <p:spPr>
           <a:xfrm>
-            <a:off x="548640" y="5532120"/>
-            <a:ext cx="3544824" cy="274320"/>
+            <a:off x="548640" y="6053286"/>
+            <a:ext cx="3544824" cy="256032"/>
           </a:xfrm>
           <a:prstGeom prst="rect">
             <a:avLst/>
@@ -19463,7 +20067,7 @@
       </p:sp>
       <p:pic>
         <p:nvPicPr>
-          <p:cNvPr id="19" name="Image 4" descr="public/projects/masakin.jpg">    </p:cNvPr>
+          <p:cNvPr id="19" name="Image 4" descr="public/profile-assets/masakin-tile.jpg">    </p:cNvPr>
           <p:cNvPicPr>
             <a:picLocks noChangeAspect="1"/>
           </p:cNvPicPr>
@@ -19471,13 +20075,14 @@
         </p:nvPicPr>
         <p:blipFill>
           <a:blip r:embed="rId5"/>
-          <a:srcRect l="0" r="0" t="0" b="0"/>
-          <a:stretch/>
+          <a:stretch>
+            <a:fillRect/>
+          </a:stretch>
         </p:blipFill>
         <p:spPr>
           <a:xfrm>
-            <a:off x="4322064" y="3840480"/>
-            <a:ext cx="3544824" cy="1417320"/>
+            <a:off x="4322064" y="4041648"/>
+            <a:ext cx="3544824" cy="1737318"/>
           </a:xfrm>
           <a:prstGeom prst="rect">
             <a:avLst/>
@@ -19492,24 +20097,24 @@
         </p:nvSpPr>
         <p:spPr>
           <a:xfrm>
-            <a:off x="4322064" y="5276088"/>
-            <a:ext cx="3544824" cy="274320"/>
-          </a:xfrm>
-          <a:prstGeom prst="rect">
-            <a:avLst/>
-          </a:prstGeom>
-          <a:noFill/>
-          <a:ln/>
-        </p:spPr>
-        <p:txBody>
-          <a:bodyPr wrap="square" rtlCol="0" anchor="ctr"/>
-          <a:lstStyle/>
-          <a:p>
-            <a:pPr indent="0" marL="0">
-              <a:buNone/>
-            </a:pPr>
-            <a:r>
-              <a:rPr lang="en-US" sz="1250" b="1" dirty="0">
+            <a:off x="4322064" y="5806398"/>
+            <a:ext cx="3544824" cy="256032"/>
+          </a:xfrm>
+          <a:prstGeom prst="rect">
+            <a:avLst/>
+          </a:prstGeom>
+          <a:noFill/>
+          <a:ln/>
+        </p:spPr>
+        <p:txBody>
+          <a:bodyPr wrap="square" rtlCol="0" anchor="ctr"/>
+          <a:lstStyle/>
+          <a:p>
+            <a:pPr indent="0" marL="0">
+              <a:buNone/>
+            </a:pPr>
+            <a:r>
+              <a:rPr lang="en-US" sz="1200" b="1" dirty="0">
                 <a:solidFill>
                   <a:srgbClr val="10232E"/>
                 </a:solidFill>
@@ -19519,7 +20124,7 @@
               </a:rPr>
               <a:t>Masakin مساكن</a:t>
             </a:r>
-            <a:endParaRPr lang="en-US" sz="1250" dirty="0"/>
+            <a:endParaRPr lang="en-US" sz="1200" dirty="0"/>
           </a:p>
         </p:txBody>
       </p:sp>
@@ -19531,8 +20136,8 @@
         </p:nvSpPr>
         <p:spPr>
           <a:xfrm>
-            <a:off x="4322064" y="5532120"/>
-            <a:ext cx="3544824" cy="274320"/>
+            <a:off x="4322064" y="6053286"/>
+            <a:ext cx="3544824" cy="256032"/>
           </a:xfrm>
           <a:prstGeom prst="rect">
             <a:avLst/>
@@ -19564,7 +20169,7 @@
       </p:sp>
       <p:pic>
         <p:nvPicPr>
-          <p:cNvPr id="22" name="Image 5" descr="public/projects/kidiverse.jpg">    </p:cNvPr>
+          <p:cNvPr id="22" name="Image 5" descr="public/profile-assets/kidiverse-tile.jpg">    </p:cNvPr>
           <p:cNvPicPr>
             <a:picLocks noChangeAspect="1"/>
           </p:cNvPicPr>
@@ -19572,13 +20177,14 @@
         </p:nvPicPr>
         <p:blipFill>
           <a:blip r:embed="rId6"/>
-          <a:srcRect l="0" r="0" t="0" b="0"/>
-          <a:stretch/>
+          <a:stretch>
+            <a:fillRect/>
+          </a:stretch>
         </p:blipFill>
         <p:spPr>
           <a:xfrm>
-            <a:off x="8095488" y="3840480"/>
-            <a:ext cx="3544824" cy="1417320"/>
+            <a:off x="8095488" y="4041648"/>
+            <a:ext cx="3544824" cy="1737318"/>
           </a:xfrm>
           <a:prstGeom prst="rect">
             <a:avLst/>
@@ -19593,24 +20199,24 @@
         </p:nvSpPr>
         <p:spPr>
           <a:xfrm>
-            <a:off x="8095488" y="5276088"/>
-            <a:ext cx="3544824" cy="274320"/>
-          </a:xfrm>
-          <a:prstGeom prst="rect">
-            <a:avLst/>
-          </a:prstGeom>
-          <a:noFill/>
-          <a:ln/>
-        </p:spPr>
-        <p:txBody>
-          <a:bodyPr wrap="square" rtlCol="0" anchor="ctr"/>
-          <a:lstStyle/>
-          <a:p>
-            <a:pPr indent="0" marL="0">
-              <a:buNone/>
-            </a:pPr>
-            <a:r>
-              <a:rPr lang="en-US" sz="1250" b="1" dirty="0">
+            <a:off x="8095488" y="5806398"/>
+            <a:ext cx="3544824" cy="256032"/>
+          </a:xfrm>
+          <a:prstGeom prst="rect">
+            <a:avLst/>
+          </a:prstGeom>
+          <a:noFill/>
+          <a:ln/>
+        </p:spPr>
+        <p:txBody>
+          <a:bodyPr wrap="square" rtlCol="0" anchor="ctr"/>
+          <a:lstStyle/>
+          <a:p>
+            <a:pPr indent="0" marL="0">
+              <a:buNone/>
+            </a:pPr>
+            <a:r>
+              <a:rPr lang="en-US" sz="1200" b="1" dirty="0">
                 <a:solidFill>
                   <a:srgbClr val="10232E"/>
                 </a:solidFill>
@@ -19620,7 +20226,7 @@
               </a:rPr>
               <a:t>KidiVerse</a:t>
             </a:r>
-            <a:endParaRPr lang="en-US" sz="1250" dirty="0"/>
+            <a:endParaRPr lang="en-US" sz="1200" dirty="0"/>
           </a:p>
         </p:txBody>
       </p:sp>
@@ -19632,8 +20238,8 @@
         </p:nvSpPr>
         <p:spPr>
           <a:xfrm>
-            <a:off x="8095488" y="5532120"/>
-            <a:ext cx="3544824" cy="274320"/>
+            <a:off x="8095488" y="6053286"/>
+            <a:ext cx="3544824" cy="256032"/>
           </a:xfrm>
           <a:prstGeom prst="rect">
             <a:avLst/>
@@ -19666,45 +20272,6 @@
       <p:sp>
         <p:nvSpPr>
           <p:cNvPr id="25" name="Text 17"/>
-          <p:cNvSpPr/>
-          <p:nvPr/>
-        </p:nvSpPr>
-        <p:spPr>
-          <a:xfrm>
-            <a:off x="548640" y="6089904"/>
-            <a:ext cx="11091672" cy="274320"/>
-          </a:xfrm>
-          <a:prstGeom prst="rect">
-            <a:avLst/>
-          </a:prstGeom>
-          <a:noFill/>
-          <a:ln/>
-        </p:spPr>
-        <p:txBody>
-          <a:bodyPr wrap="square" rtlCol="0" anchor="ctr"/>
-          <a:lstStyle/>
-          <a:p>
-            <a:pPr indent="0" marL="0">
-              <a:buNone/>
-            </a:pPr>
-            <a:r>
-              <a:rPr lang="en-US" sz="900" i="1" dirty="0">
-                <a:solidFill>
-                  <a:srgbClr val="52677A"/>
-                </a:solidFill>
-                <a:latin typeface="Segoe UI" pitchFamily="34" charset="0"/>
-                <a:ea typeface="Segoe UI" pitchFamily="34" charset="-122"/>
-                <a:cs typeface="Segoe UI" pitchFamily="34" charset="-120"/>
-              </a:rPr>
-              <a:t>Every venture above was launched pre-market with WeThink as the end-to-end technology partner.</a:t>
-            </a:r>
-            <a:endParaRPr lang="en-US" sz="900" dirty="0"/>
-          </a:p>
-        </p:txBody>
-      </p:sp>
-      <p:sp>
-        <p:nvSpPr>
-          <p:cNvPr id="26" name="Text 18"/>
           <p:cNvSpPr/>
           <p:nvPr/>
         </p:nvSpPr>
@@ -19757,7 +20324,7 @@
       </p:sp>
       <p:sp>
         <p:nvSpPr>
-          <p:cNvPr id="27" name="Text 19"/>
+          <p:cNvPr id="26" name="Text 18"/>
           <p:cNvSpPr/>
           <p:nvPr/>
         </p:nvSpPr>
@@ -19889,7 +20456,7 @@
                 <a:ea typeface="Segoe UI" pitchFamily="34" charset="-122"/>
                 <a:cs typeface="Segoe UI" pitchFamily="34" charset="-120"/>
               </a:rPr>
-              <a:t>Case Studies</a:t>
+              <a:t>Featured Cases</a:t>
             </a:r>
             <a:endParaRPr lang="en-US" sz="2600" dirty="0"/>
           </a:p>
@@ -19914,14 +20481,53 @@
       </p:sp>
       <p:sp>
         <p:nvSpPr>
-          <p:cNvPr id="6" name="Shape 4"/>
-          <p:cNvSpPr/>
-          <p:nvPr/>
-        </p:nvSpPr>
-        <p:spPr>
-          <a:xfrm>
-            <a:off x="548640" y="1417320"/>
-            <a:ext cx="3468624" cy="4572000"/>
+          <p:cNvPr id="6" name="Text 4"/>
+          <p:cNvSpPr/>
+          <p:nvPr/>
+        </p:nvSpPr>
+        <p:spPr>
+          <a:xfrm>
+            <a:off x="548640" y="1078992"/>
+            <a:ext cx="11091672" cy="256032"/>
+          </a:xfrm>
+          <a:prstGeom prst="rect">
+            <a:avLst/>
+          </a:prstGeom>
+          <a:noFill/>
+          <a:ln/>
+        </p:spPr>
+        <p:txBody>
+          <a:bodyPr wrap="square" rtlCol="0" anchor="ctr"/>
+          <a:lstStyle/>
+          <a:p>
+            <a:pPr indent="0" marL="0">
+              <a:buNone/>
+            </a:pPr>
+            <a:r>
+              <a:rPr lang="en-US" sz="1000" b="1" spc="200" kern="0" dirty="0">
+                <a:solidFill>
+                  <a:srgbClr val="0E9384"/>
+                </a:solidFill>
+                <a:latin typeface="Segoe UI" pitchFamily="34" charset="0"/>
+                <a:ea typeface="Segoe UI" pitchFamily="34" charset="-122"/>
+                <a:cs typeface="Segoe UI" pitchFamily="34" charset="-120"/>
+              </a:rPr>
+              <a:t>OUR MOST RECENT &amp; MOST CREATIVE WORK</a:t>
+            </a:r>
+            <a:endParaRPr lang="en-US" sz="1000" dirty="0"/>
+          </a:p>
+        </p:txBody>
+      </p:sp>
+      <p:sp>
+        <p:nvSpPr>
+          <p:cNvPr id="7" name="Shape 5"/>
+          <p:cNvSpPr/>
+          <p:nvPr/>
+        </p:nvSpPr>
+        <p:spPr>
+          <a:xfrm>
+            <a:off x="548640" y="1463040"/>
+            <a:ext cx="3468624" cy="4709160"/>
           </a:xfrm>
           <a:prstGeom prst="roundRect">
             <a:avLst>
@@ -19941,13 +20547,13 @@
       </p:sp>
       <p:sp>
         <p:nvSpPr>
-          <p:cNvPr id="7" name="Shape 5"/>
-          <p:cNvSpPr/>
-          <p:nvPr/>
-        </p:nvSpPr>
-        <p:spPr>
-          <a:xfrm>
-            <a:off x="548640" y="1417320"/>
+          <p:cNvPr id="8" name="Shape 6"/>
+          <p:cNvSpPr/>
+          <p:nvPr/>
+        </p:nvSpPr>
+        <p:spPr>
+          <a:xfrm>
+            <a:off x="548640" y="1463040"/>
             <a:ext cx="3468624" cy="64008"/>
           </a:xfrm>
           <a:prstGeom prst="rect">
@@ -19959,15 +20565,39 @@
           <a:ln/>
         </p:spPr>
       </p:sp>
-      <p:sp>
-        <p:nvSpPr>
-          <p:cNvPr id="8" name="Text 6"/>
-          <p:cNvSpPr/>
-          <p:nvPr/>
-        </p:nvSpPr>
-        <p:spPr>
-          <a:xfrm>
-            <a:off x="777240" y="1618488"/>
+      <p:pic>
+        <p:nvPicPr>
+          <p:cNvPr id="9" name="Image 0" descr="public/logos/albina-alareeq.png">    </p:cNvPr>
+          <p:cNvPicPr>
+            <a:picLocks noChangeAspect="1"/>
+          </p:cNvPicPr>
+          <p:nvPr/>
+        </p:nvPicPr>
+        <p:blipFill>
+          <a:blip r:embed="rId1"/>
+          <a:stretch>
+            <a:fillRect/>
+          </a:stretch>
+        </p:blipFill>
+        <p:spPr>
+          <a:xfrm>
+            <a:off x="1414272" y="1691640"/>
+            <a:ext cx="1737360" cy="1042416"/>
+          </a:xfrm>
+          <a:prstGeom prst="rect">
+            <a:avLst/>
+          </a:prstGeom>
+        </p:spPr>
+      </p:pic>
+      <p:sp>
+        <p:nvSpPr>
+          <p:cNvPr id="10" name="Text 7"/>
+          <p:cNvSpPr/>
+          <p:nvPr/>
+        </p:nvSpPr>
+        <p:spPr>
+          <a:xfrm>
+            <a:off x="777240" y="2816352"/>
             <a:ext cx="3011424" cy="256032"/>
           </a:xfrm>
           <a:prstGeom prst="rect">
@@ -19980,7 +20610,7 @@
           <a:bodyPr wrap="square" rtlCol="0" anchor="ctr"/>
           <a:lstStyle/>
           <a:p>
-            <a:pPr indent="0" marL="0">
+            <a:pPr algn="ctr" indent="0" marL="0">
               <a:buNone/>
             </a:pPr>
             <a:r>
@@ -20000,33 +20630,33 @@
       </p:sp>
       <p:sp>
         <p:nvSpPr>
-          <p:cNvPr id="9" name="Text 7"/>
-          <p:cNvSpPr/>
-          <p:nvPr/>
-        </p:nvSpPr>
-        <p:spPr>
-          <a:xfrm>
-            <a:off x="777240" y="1874520"/>
-            <a:ext cx="3011424" cy="731520"/>
-          </a:xfrm>
-          <a:prstGeom prst="rect">
-            <a:avLst/>
-          </a:prstGeom>
-          <a:noFill/>
-          <a:ln/>
-        </p:spPr>
-        <p:txBody>
-          <a:bodyPr wrap="square" rtlCol="0" anchor="ctr"/>
-          <a:lstStyle/>
-          <a:p>
-            <a:pPr indent="0" marL="0">
+          <p:cNvPr id="11" name="Text 8"/>
+          <p:cNvSpPr/>
+          <p:nvPr/>
+        </p:nvSpPr>
+        <p:spPr>
+          <a:xfrm>
+            <a:off x="777240" y="3072384"/>
+            <a:ext cx="3011424" cy="685800"/>
+          </a:xfrm>
+          <a:prstGeom prst="rect">
+            <a:avLst/>
+          </a:prstGeom>
+          <a:noFill/>
+          <a:ln/>
+        </p:spPr>
+        <p:txBody>
+          <a:bodyPr wrap="square" rtlCol="0" anchor="ctr"/>
+          <a:lstStyle/>
+          <a:p>
+            <a:pPr algn="ctr" indent="0" marL="0">
               <a:lnSpc>
-                <a:spcPts val="1700"/>
+                <a:spcPts val="1600"/>
               </a:lnSpc>
               <a:buNone/>
             </a:pPr>
             <a:r>
-              <a:rPr lang="en-US" sz="1400" b="1" dirty="0">
+              <a:rPr lang="en-US" sz="1350" b="1" dirty="0">
                 <a:solidFill>
                   <a:srgbClr val="10232E"/>
                 </a:solidFill>
@@ -20036,39 +20666,39 @@
               </a:rPr>
               <a:t>Albina Alareeq Digital Hub</a:t>
             </a:r>
-            <a:endParaRPr lang="en-US" sz="1400" dirty="0"/>
-          </a:p>
-        </p:txBody>
-      </p:sp>
-      <p:sp>
-        <p:nvSpPr>
-          <p:cNvPr id="10" name="Text 8"/>
-          <p:cNvSpPr/>
-          <p:nvPr/>
-        </p:nvSpPr>
-        <p:spPr>
-          <a:xfrm>
-            <a:off x="777240" y="2697480"/>
-            <a:ext cx="3011424" cy="1874520"/>
-          </a:xfrm>
-          <a:prstGeom prst="rect">
-            <a:avLst/>
-          </a:prstGeom>
-          <a:noFill/>
-          <a:ln/>
-        </p:spPr>
-        <p:txBody>
-          <a:bodyPr wrap="square" rtlCol="0" anchor="ctr"/>
-          <a:lstStyle/>
-          <a:p>
-            <a:pPr indent="0" marL="0">
+            <a:endParaRPr lang="en-US" sz="1350" dirty="0"/>
+          </a:p>
+        </p:txBody>
+      </p:sp>
+      <p:sp>
+        <p:nvSpPr>
+          <p:cNvPr id="12" name="Text 9"/>
+          <p:cNvSpPr/>
+          <p:nvPr/>
+        </p:nvSpPr>
+        <p:spPr>
+          <a:xfrm>
+            <a:off x="777240" y="3803904"/>
+            <a:ext cx="3011424" cy="1600200"/>
+          </a:xfrm>
+          <a:prstGeom prst="rect">
+            <a:avLst/>
+          </a:prstGeom>
+          <a:noFill/>
+          <a:ln/>
+        </p:spPr>
+        <p:txBody>
+          <a:bodyPr wrap="square" rtlCol="0" anchor="ctr"/>
+          <a:lstStyle/>
+          <a:p>
+            <a:pPr algn="ctr" indent="0" marL="0">
               <a:lnSpc>
-                <a:spcPts val="1400"/>
+                <a:spcPts val="1300"/>
               </a:lnSpc>
               <a:buNone/>
             </a:pPr>
             <a:r>
-              <a:rPr lang="en-US" sz="1000" dirty="0">
+              <a:rPr lang="en-US" sz="950" dirty="0">
                 <a:solidFill>
                   <a:srgbClr val="3A4A56"/>
                 </a:solidFill>
@@ -20076,61 +20706,22 @@
                 <a:ea typeface="Segoe UI" pitchFamily="34" charset="-122"/>
                 <a:cs typeface="Segoe UI" pitchFamily="34" charset="-120"/>
               </a:rPr>
-              <a:t>End-to-end digital transformation for a major Abu Dhabi construction firm — a brand-aligned corporate website plus a connected project-management portal unifying field reporting and head-office visibility.</a:t>
-            </a:r>
-            <a:endParaRPr lang="en-US" sz="1000" dirty="0"/>
-          </a:p>
-        </p:txBody>
-      </p:sp>
-      <p:sp>
-        <p:nvSpPr>
-          <p:cNvPr id="11" name="Text 9"/>
-          <p:cNvSpPr/>
-          <p:nvPr/>
-        </p:nvSpPr>
-        <p:spPr>
-          <a:xfrm>
-            <a:off x="777240" y="4636008"/>
-            <a:ext cx="3011424" cy="228600"/>
-          </a:xfrm>
-          <a:prstGeom prst="rect">
-            <a:avLst/>
-          </a:prstGeom>
-          <a:noFill/>
-          <a:ln/>
-        </p:spPr>
-        <p:txBody>
-          <a:bodyPr wrap="square" rtlCol="0" anchor="ctr"/>
-          <a:lstStyle/>
-          <a:p>
-            <a:pPr indent="0" marL="0">
-              <a:buNone/>
-            </a:pPr>
-            <a:r>
-              <a:rPr lang="en-US" sz="750" b="1" spc="200" kern="0" dirty="0">
-                <a:solidFill>
-                  <a:srgbClr val="52677A"/>
-                </a:solidFill>
-                <a:latin typeface="Segoe UI" pitchFamily="34" charset="0"/>
-                <a:ea typeface="Segoe UI" pitchFamily="34" charset="-122"/>
-                <a:cs typeface="Segoe UI" pitchFamily="34" charset="-120"/>
-              </a:rPr>
-              <a:t>DELIVERED</a:t>
-            </a:r>
-            <a:endParaRPr lang="en-US" sz="750" dirty="0"/>
-          </a:p>
-        </p:txBody>
-      </p:sp>
-      <p:sp>
-        <p:nvSpPr>
-          <p:cNvPr id="12" name="Shape 10"/>
-          <p:cNvSpPr/>
-          <p:nvPr/>
-        </p:nvSpPr>
-        <p:spPr>
-          <a:xfrm>
-            <a:off x="777240" y="4892040"/>
-            <a:ext cx="3011424" cy="292608"/>
+              <a:t>End-to-end digital transformation for a major Abu Dhabi contracting firm — a brand-aligned corporate website plus a connected project-management portal unifying field reporting and head-office visibility.</a:t>
+            </a:r>
+            <a:endParaRPr lang="en-US" sz="950" dirty="0"/>
+          </a:p>
+        </p:txBody>
+      </p:sp>
+      <p:sp>
+        <p:nvSpPr>
+          <p:cNvPr id="13" name="Shape 10"/>
+          <p:cNvSpPr/>
+          <p:nvPr/>
+        </p:nvSpPr>
+        <p:spPr>
+          <a:xfrm>
+            <a:off x="868680" y="5074920"/>
+            <a:ext cx="2828544" cy="292608"/>
           </a:xfrm>
           <a:prstGeom prst="roundRect">
             <a:avLst>
@@ -20150,14 +20741,14 @@
       </p:sp>
       <p:sp>
         <p:nvSpPr>
-          <p:cNvPr id="13" name="Text 11"/>
-          <p:cNvSpPr/>
-          <p:nvPr/>
-        </p:nvSpPr>
-        <p:spPr>
-          <a:xfrm>
-            <a:off x="777240" y="4884725"/>
-            <a:ext cx="3011424" cy="310896"/>
+          <p:cNvPr id="14" name="Text 11"/>
+          <p:cNvSpPr/>
+          <p:nvPr/>
+        </p:nvSpPr>
+        <p:spPr>
+          <a:xfrm>
+            <a:off x="868680" y="5067605"/>
+            <a:ext cx="2828544" cy="310896"/>
           </a:xfrm>
           <a:prstGeom prst="rect">
             <a:avLst/>
@@ -20189,14 +20780,14 @@
       </p:sp>
       <p:sp>
         <p:nvSpPr>
-          <p:cNvPr id="14" name="Shape 12"/>
-          <p:cNvSpPr/>
-          <p:nvPr/>
-        </p:nvSpPr>
-        <p:spPr>
-          <a:xfrm>
-            <a:off x="777240" y="5239512"/>
-            <a:ext cx="3011424" cy="292608"/>
+          <p:cNvPr id="15" name="Shape 12"/>
+          <p:cNvSpPr/>
+          <p:nvPr/>
+        </p:nvSpPr>
+        <p:spPr>
+          <a:xfrm>
+            <a:off x="868680" y="5422392"/>
+            <a:ext cx="2828544" cy="292608"/>
           </a:xfrm>
           <a:prstGeom prst="roundRect">
             <a:avLst>
@@ -20216,14 +20807,14 @@
       </p:sp>
       <p:sp>
         <p:nvSpPr>
-          <p:cNvPr id="15" name="Text 13"/>
-          <p:cNvSpPr/>
-          <p:nvPr/>
-        </p:nvSpPr>
-        <p:spPr>
-          <a:xfrm>
-            <a:off x="777240" y="5232197"/>
-            <a:ext cx="3011424" cy="310896"/>
+          <p:cNvPr id="16" name="Text 13"/>
+          <p:cNvSpPr/>
+          <p:nvPr/>
+        </p:nvSpPr>
+        <p:spPr>
+          <a:xfrm>
+            <a:off x="868680" y="5415077"/>
+            <a:ext cx="2828544" cy="310896"/>
           </a:xfrm>
           <a:prstGeom prst="rect">
             <a:avLst/>
@@ -20255,14 +20846,14 @@
       </p:sp>
       <p:sp>
         <p:nvSpPr>
-          <p:cNvPr id="16" name="Shape 14"/>
-          <p:cNvSpPr/>
-          <p:nvPr/>
-        </p:nvSpPr>
-        <p:spPr>
-          <a:xfrm>
-            <a:off x="777240" y="5586984"/>
-            <a:ext cx="3011424" cy="292608"/>
+          <p:cNvPr id="17" name="Shape 14"/>
+          <p:cNvSpPr/>
+          <p:nvPr/>
+        </p:nvSpPr>
+        <p:spPr>
+          <a:xfrm>
+            <a:off x="868680" y="5769864"/>
+            <a:ext cx="2828544" cy="292608"/>
           </a:xfrm>
           <a:prstGeom prst="roundRect">
             <a:avLst>
@@ -20282,14 +20873,14 @@
       </p:sp>
       <p:sp>
         <p:nvSpPr>
-          <p:cNvPr id="17" name="Text 15"/>
-          <p:cNvSpPr/>
-          <p:nvPr/>
-        </p:nvSpPr>
-        <p:spPr>
-          <a:xfrm>
-            <a:off x="777240" y="5579669"/>
-            <a:ext cx="3011424" cy="310896"/>
+          <p:cNvPr id="18" name="Text 15"/>
+          <p:cNvSpPr/>
+          <p:nvPr/>
+        </p:nvSpPr>
+        <p:spPr>
+          <a:xfrm>
+            <a:off x="868680" y="5762549"/>
+            <a:ext cx="2828544" cy="310896"/>
           </a:xfrm>
           <a:prstGeom prst="rect">
             <a:avLst/>
@@ -20321,14 +20912,14 @@
       </p:sp>
       <p:sp>
         <p:nvSpPr>
-          <p:cNvPr id="18" name="Shape 16"/>
-          <p:cNvSpPr/>
-          <p:nvPr/>
-        </p:nvSpPr>
-        <p:spPr>
-          <a:xfrm>
-            <a:off x="4245864" y="1417320"/>
-            <a:ext cx="3468624" cy="4572000"/>
+          <p:cNvPr id="19" name="Shape 16"/>
+          <p:cNvSpPr/>
+          <p:nvPr/>
+        </p:nvSpPr>
+        <p:spPr>
+          <a:xfrm>
+            <a:off x="4245864" y="1463040"/>
+            <a:ext cx="3468624" cy="4709160"/>
           </a:xfrm>
           <a:prstGeom prst="roundRect">
             <a:avLst>
@@ -20348,33 +20939,57 @@
       </p:sp>
       <p:sp>
         <p:nvSpPr>
-          <p:cNvPr id="19" name="Shape 17"/>
-          <p:cNvSpPr/>
-          <p:nvPr/>
-        </p:nvSpPr>
-        <p:spPr>
-          <a:xfrm>
-            <a:off x="4245864" y="1417320"/>
+          <p:cNvPr id="20" name="Shape 17"/>
+          <p:cNvSpPr/>
+          <p:nvPr/>
+        </p:nvSpPr>
+        <p:spPr>
+          <a:xfrm>
+            <a:off x="4245864" y="1463040"/>
             <a:ext cx="3468624" cy="64008"/>
           </a:xfrm>
           <a:prstGeom prst="rect">
             <a:avLst/>
           </a:prstGeom>
           <a:solidFill>
-            <a:srgbClr val="7C3AED"/>
+            <a:srgbClr val="F87171"/>
           </a:solidFill>
           <a:ln/>
         </p:spPr>
       </p:sp>
-      <p:sp>
-        <p:nvSpPr>
-          <p:cNvPr id="20" name="Text 18"/>
-          <p:cNvSpPr/>
-          <p:nvPr/>
-        </p:nvSpPr>
-        <p:spPr>
-          <a:xfrm>
-            <a:off x="4474464" y="1618488"/>
+      <p:pic>
+        <p:nvPicPr>
+          <p:cNvPr id="21" name="Image 1" descr="public/logos/nabe-eldiyafa.png">    </p:cNvPr>
+          <p:cNvPicPr>
+            <a:picLocks noChangeAspect="1"/>
+          </p:cNvPicPr>
+          <p:nvPr/>
+        </p:nvPicPr>
+        <p:blipFill>
+          <a:blip r:embed="rId2"/>
+          <a:stretch>
+            <a:fillRect/>
+          </a:stretch>
+        </p:blipFill>
+        <p:spPr>
+          <a:xfrm>
+            <a:off x="5111496" y="1691640"/>
+            <a:ext cx="1737360" cy="1042416"/>
+          </a:xfrm>
+          <a:prstGeom prst="rect">
+            <a:avLst/>
+          </a:prstGeom>
+        </p:spPr>
+      </p:pic>
+      <p:sp>
+        <p:nvSpPr>
+          <p:cNvPr id="22" name="Text 18"/>
+          <p:cNvSpPr/>
+          <p:nvPr/>
+        </p:nvSpPr>
+        <p:spPr>
+          <a:xfrm>
+            <a:off x="4474464" y="2816352"/>
             <a:ext cx="3011424" cy="256032"/>
           </a:xfrm>
           <a:prstGeom prst="rect">
@@ -20387,13 +21002,13 @@
           <a:bodyPr wrap="square" rtlCol="0" anchor="ctr"/>
           <a:lstStyle/>
           <a:p>
-            <a:pPr indent="0" marL="0">
+            <a:pPr algn="ctr" indent="0" marL="0">
               <a:buNone/>
             </a:pPr>
             <a:r>
               <a:rPr lang="en-US" sz="800" b="1" spc="150" kern="0" dirty="0">
                 <a:solidFill>
-                  <a:srgbClr val="7C3AED"/>
+                  <a:srgbClr val="F87171"/>
                 </a:solidFill>
                 <a:latin typeface="Segoe UI" pitchFamily="34" charset="0"/>
                 <a:ea typeface="Segoe UI" pitchFamily="34" charset="-122"/>
@@ -20407,33 +21022,33 @@
       </p:sp>
       <p:sp>
         <p:nvSpPr>
-          <p:cNvPr id="21" name="Text 19"/>
-          <p:cNvSpPr/>
-          <p:nvPr/>
-        </p:nvSpPr>
-        <p:spPr>
-          <a:xfrm>
-            <a:off x="4474464" y="1874520"/>
-            <a:ext cx="3011424" cy="731520"/>
-          </a:xfrm>
-          <a:prstGeom prst="rect">
-            <a:avLst/>
-          </a:prstGeom>
-          <a:noFill/>
-          <a:ln/>
-        </p:spPr>
-        <p:txBody>
-          <a:bodyPr wrap="square" rtlCol="0" anchor="ctr"/>
-          <a:lstStyle/>
-          <a:p>
-            <a:pPr indent="0" marL="0">
+          <p:cNvPr id="23" name="Text 19"/>
+          <p:cNvSpPr/>
+          <p:nvPr/>
+        </p:nvSpPr>
+        <p:spPr>
+          <a:xfrm>
+            <a:off x="4474464" y="3072384"/>
+            <a:ext cx="3011424" cy="685800"/>
+          </a:xfrm>
+          <a:prstGeom prst="rect">
+            <a:avLst/>
+          </a:prstGeom>
+          <a:noFill/>
+          <a:ln/>
+        </p:spPr>
+        <p:txBody>
+          <a:bodyPr wrap="square" rtlCol="0" anchor="ctr"/>
+          <a:lstStyle/>
+          <a:p>
+            <a:pPr algn="ctr" indent="0" marL="0">
               <a:lnSpc>
-                <a:spcPts val="1700"/>
+                <a:spcPts val="1600"/>
               </a:lnSpc>
               <a:buNone/>
             </a:pPr>
             <a:r>
-              <a:rPr lang="en-US" sz="1400" b="1" dirty="0">
+              <a:rPr lang="en-US" sz="1350" b="1" dirty="0">
                 <a:solidFill>
                   <a:srgbClr val="10232E"/>
                 </a:solidFill>
@@ -20443,39 +21058,39 @@
               </a:rPr>
               <a:t>Nabe Eldiyafa Brand &amp; Digital Ecosystem</a:t>
             </a:r>
-            <a:endParaRPr lang="en-US" sz="1400" dirty="0"/>
-          </a:p>
-        </p:txBody>
-      </p:sp>
-      <p:sp>
-        <p:nvSpPr>
-          <p:cNvPr id="22" name="Text 20"/>
-          <p:cNvSpPr/>
-          <p:nvPr/>
-        </p:nvSpPr>
-        <p:spPr>
-          <a:xfrm>
-            <a:off x="4474464" y="2697480"/>
-            <a:ext cx="3011424" cy="1874520"/>
-          </a:xfrm>
-          <a:prstGeom prst="rect">
-            <a:avLst/>
-          </a:prstGeom>
-          <a:noFill/>
-          <a:ln/>
-        </p:spPr>
-        <p:txBody>
-          <a:bodyPr wrap="square" rtlCol="0" anchor="ctr"/>
-          <a:lstStyle/>
-          <a:p>
-            <a:pPr indent="0" marL="0">
+            <a:endParaRPr lang="en-US" sz="1350" dirty="0"/>
+          </a:p>
+        </p:txBody>
+      </p:sp>
+      <p:sp>
+        <p:nvSpPr>
+          <p:cNvPr id="24" name="Text 20"/>
+          <p:cNvSpPr/>
+          <p:nvPr/>
+        </p:nvSpPr>
+        <p:spPr>
+          <a:xfrm>
+            <a:off x="4474464" y="3803904"/>
+            <a:ext cx="3011424" cy="1600200"/>
+          </a:xfrm>
+          <a:prstGeom prst="rect">
+            <a:avLst/>
+          </a:prstGeom>
+          <a:noFill/>
+          <a:ln/>
+        </p:spPr>
+        <p:txBody>
+          <a:bodyPr wrap="square" rtlCol="0" anchor="ctr"/>
+          <a:lstStyle/>
+          <a:p>
+            <a:pPr algn="ctr" indent="0" marL="0">
               <a:lnSpc>
-                <a:spcPts val="1400"/>
+                <a:spcPts val="1300"/>
               </a:lnSpc>
               <a:buNone/>
             </a:pPr>
             <a:r>
-              <a:rPr lang="en-US" sz="1000" dirty="0">
+              <a:rPr lang="en-US" sz="950" dirty="0">
                 <a:solidFill>
                   <a:srgbClr val="3A4A56"/>
                 </a:solidFill>
@@ -20485,59 +21100,20 @@
               </a:rPr>
               <a:t>Full digital launch for a heritage Damascene restaurant — brand identity refresh, a bilingual reservations website, and a 12-month social media programme that filled weekend covers.</a:t>
             </a:r>
-            <a:endParaRPr lang="en-US" sz="1000" dirty="0"/>
-          </a:p>
-        </p:txBody>
-      </p:sp>
-      <p:sp>
-        <p:nvSpPr>
-          <p:cNvPr id="23" name="Text 21"/>
-          <p:cNvSpPr/>
-          <p:nvPr/>
-        </p:nvSpPr>
-        <p:spPr>
-          <a:xfrm>
-            <a:off x="4474464" y="4636008"/>
-            <a:ext cx="3011424" cy="228600"/>
-          </a:xfrm>
-          <a:prstGeom prst="rect">
-            <a:avLst/>
-          </a:prstGeom>
-          <a:noFill/>
-          <a:ln/>
-        </p:spPr>
-        <p:txBody>
-          <a:bodyPr wrap="square" rtlCol="0" anchor="ctr"/>
-          <a:lstStyle/>
-          <a:p>
-            <a:pPr indent="0" marL="0">
-              <a:buNone/>
-            </a:pPr>
-            <a:r>
-              <a:rPr lang="en-US" sz="750" b="1" spc="200" kern="0" dirty="0">
-                <a:solidFill>
-                  <a:srgbClr val="52677A"/>
-                </a:solidFill>
-                <a:latin typeface="Segoe UI" pitchFamily="34" charset="0"/>
-                <a:ea typeface="Segoe UI" pitchFamily="34" charset="-122"/>
-                <a:cs typeface="Segoe UI" pitchFamily="34" charset="-120"/>
-              </a:rPr>
-              <a:t>DELIVERED</a:t>
-            </a:r>
-            <a:endParaRPr lang="en-US" sz="750" dirty="0"/>
-          </a:p>
-        </p:txBody>
-      </p:sp>
-      <p:sp>
-        <p:nvSpPr>
-          <p:cNvPr id="24" name="Shape 22"/>
-          <p:cNvSpPr/>
-          <p:nvPr/>
-        </p:nvSpPr>
-        <p:spPr>
-          <a:xfrm>
-            <a:off x="4474464" y="4892040"/>
-            <a:ext cx="3011424" cy="292608"/>
+            <a:endParaRPr lang="en-US" sz="950" dirty="0"/>
+          </a:p>
+        </p:txBody>
+      </p:sp>
+      <p:sp>
+        <p:nvSpPr>
+          <p:cNvPr id="25" name="Shape 21"/>
+          <p:cNvSpPr/>
+          <p:nvPr/>
+        </p:nvSpPr>
+        <p:spPr>
+          <a:xfrm>
+            <a:off x="4565904" y="5074920"/>
+            <a:ext cx="2828544" cy="292608"/>
           </a:xfrm>
           <a:prstGeom prst="roundRect">
             <a:avLst>
@@ -20549,7 +21125,7 @@
           </a:solidFill>
           <a:ln w="9525">
             <a:solidFill>
-              <a:srgbClr val="7C3AED"/>
+              <a:srgbClr val="F87171"/>
             </a:solidFill>
             <a:prstDash val="solid"/>
           </a:ln>
@@ -20557,14 +21133,14 @@
       </p:sp>
       <p:sp>
         <p:nvSpPr>
-          <p:cNvPr id="25" name="Text 23"/>
-          <p:cNvSpPr/>
-          <p:nvPr/>
-        </p:nvSpPr>
-        <p:spPr>
-          <a:xfrm>
-            <a:off x="4474464" y="4884725"/>
-            <a:ext cx="3011424" cy="310896"/>
+          <p:cNvPr id="26" name="Text 22"/>
+          <p:cNvSpPr/>
+          <p:nvPr/>
+        </p:nvSpPr>
+        <p:spPr>
+          <a:xfrm>
+            <a:off x="4565904" y="5067605"/>
+            <a:ext cx="2828544" cy="310896"/>
           </a:xfrm>
           <a:prstGeom prst="rect">
             <a:avLst/>
@@ -20582,7 +21158,7 @@
             <a:r>
               <a:rPr lang="en-US" sz="850" b="1" dirty="0">
                 <a:solidFill>
-                  <a:srgbClr val="7C3AED"/>
+                  <a:srgbClr val="F87171"/>
                 </a:solidFill>
                 <a:latin typeface="Segoe UI" pitchFamily="34" charset="0"/>
                 <a:ea typeface="Segoe UI" pitchFamily="34" charset="-122"/>
@@ -20596,14 +21172,14 @@
       </p:sp>
       <p:sp>
         <p:nvSpPr>
-          <p:cNvPr id="26" name="Shape 24"/>
-          <p:cNvSpPr/>
-          <p:nvPr/>
-        </p:nvSpPr>
-        <p:spPr>
-          <a:xfrm>
-            <a:off x="4474464" y="5239512"/>
-            <a:ext cx="3011424" cy="292608"/>
+          <p:cNvPr id="27" name="Shape 23"/>
+          <p:cNvSpPr/>
+          <p:nvPr/>
+        </p:nvSpPr>
+        <p:spPr>
+          <a:xfrm>
+            <a:off x="4565904" y="5422392"/>
+            <a:ext cx="2828544" cy="292608"/>
           </a:xfrm>
           <a:prstGeom prst="roundRect">
             <a:avLst>
@@ -20615,7 +21191,7 @@
           </a:solidFill>
           <a:ln w="9525">
             <a:solidFill>
-              <a:srgbClr val="7C3AED"/>
+              <a:srgbClr val="F87171"/>
             </a:solidFill>
             <a:prstDash val="solid"/>
           </a:ln>
@@ -20623,14 +21199,14 @@
       </p:sp>
       <p:sp>
         <p:nvSpPr>
-          <p:cNvPr id="27" name="Text 25"/>
-          <p:cNvSpPr/>
-          <p:nvPr/>
-        </p:nvSpPr>
-        <p:spPr>
-          <a:xfrm>
-            <a:off x="4474464" y="5232197"/>
-            <a:ext cx="3011424" cy="310896"/>
+          <p:cNvPr id="28" name="Text 24"/>
+          <p:cNvSpPr/>
+          <p:nvPr/>
+        </p:nvSpPr>
+        <p:spPr>
+          <a:xfrm>
+            <a:off x="4565904" y="5415077"/>
+            <a:ext cx="2828544" cy="310896"/>
           </a:xfrm>
           <a:prstGeom prst="rect">
             <a:avLst/>
@@ -20648,7 +21224,7 @@
             <a:r>
               <a:rPr lang="en-US" sz="850" b="1" dirty="0">
                 <a:solidFill>
-                  <a:srgbClr val="7C3AED"/>
+                  <a:srgbClr val="F87171"/>
                 </a:solidFill>
                 <a:latin typeface="Segoe UI" pitchFamily="34" charset="0"/>
                 <a:ea typeface="Segoe UI" pitchFamily="34" charset="-122"/>
@@ -20662,14 +21238,14 @@
       </p:sp>
       <p:sp>
         <p:nvSpPr>
-          <p:cNvPr id="28" name="Shape 26"/>
-          <p:cNvSpPr/>
-          <p:nvPr/>
-        </p:nvSpPr>
-        <p:spPr>
-          <a:xfrm>
-            <a:off x="4474464" y="5586984"/>
-            <a:ext cx="3011424" cy="292608"/>
+          <p:cNvPr id="29" name="Shape 25"/>
+          <p:cNvSpPr/>
+          <p:nvPr/>
+        </p:nvSpPr>
+        <p:spPr>
+          <a:xfrm>
+            <a:off x="4565904" y="5769864"/>
+            <a:ext cx="2828544" cy="292608"/>
           </a:xfrm>
           <a:prstGeom prst="roundRect">
             <a:avLst>
@@ -20681,7 +21257,7 @@
           </a:solidFill>
           <a:ln w="9525">
             <a:solidFill>
-              <a:srgbClr val="7C3AED"/>
+              <a:srgbClr val="F87171"/>
             </a:solidFill>
             <a:prstDash val="solid"/>
           </a:ln>
@@ -20689,14 +21265,14 @@
       </p:sp>
       <p:sp>
         <p:nvSpPr>
-          <p:cNvPr id="29" name="Text 27"/>
-          <p:cNvSpPr/>
-          <p:nvPr/>
-        </p:nvSpPr>
-        <p:spPr>
-          <a:xfrm>
-            <a:off x="4474464" y="5579669"/>
-            <a:ext cx="3011424" cy="310896"/>
+          <p:cNvPr id="30" name="Text 26"/>
+          <p:cNvSpPr/>
+          <p:nvPr/>
+        </p:nvSpPr>
+        <p:spPr>
+          <a:xfrm>
+            <a:off x="4565904" y="5762549"/>
+            <a:ext cx="2828544" cy="310896"/>
           </a:xfrm>
           <a:prstGeom prst="rect">
             <a:avLst/>
@@ -20714,7 +21290,7 @@
             <a:r>
               <a:rPr lang="en-US" sz="850" b="1" dirty="0">
                 <a:solidFill>
-                  <a:srgbClr val="7C3AED"/>
+                  <a:srgbClr val="F87171"/>
                 </a:solidFill>
                 <a:latin typeface="Segoe UI" pitchFamily="34" charset="0"/>
                 <a:ea typeface="Segoe UI" pitchFamily="34" charset="-122"/>
@@ -20728,14 +21304,14 @@
       </p:sp>
       <p:sp>
         <p:nvSpPr>
-          <p:cNvPr id="30" name="Shape 28"/>
-          <p:cNvSpPr/>
-          <p:nvPr/>
-        </p:nvSpPr>
-        <p:spPr>
-          <a:xfrm>
-            <a:off x="7943088" y="1417320"/>
-            <a:ext cx="3468624" cy="4572000"/>
+          <p:cNvPr id="31" name="Shape 27"/>
+          <p:cNvSpPr/>
+          <p:nvPr/>
+        </p:nvSpPr>
+        <p:spPr>
+          <a:xfrm>
+            <a:off x="7943088" y="1463040"/>
+            <a:ext cx="3468624" cy="4709160"/>
           </a:xfrm>
           <a:prstGeom prst="roundRect">
             <a:avLst>
@@ -20755,33 +21331,57 @@
       </p:sp>
       <p:sp>
         <p:nvSpPr>
-          <p:cNvPr id="31" name="Shape 29"/>
-          <p:cNvSpPr/>
-          <p:nvPr/>
-        </p:nvSpPr>
-        <p:spPr>
-          <a:xfrm>
-            <a:off x="7943088" y="1417320"/>
+          <p:cNvPr id="32" name="Shape 28"/>
+          <p:cNvSpPr/>
+          <p:nvPr/>
+        </p:nvSpPr>
+        <p:spPr>
+          <a:xfrm>
+            <a:off x="7943088" y="1463040"/>
             <a:ext cx="3468624" cy="64008"/>
           </a:xfrm>
           <a:prstGeom prst="rect">
             <a:avLst/>
           </a:prstGeom>
           <a:solidFill>
-            <a:srgbClr val="38BDF8"/>
+            <a:srgbClr val="F59E0B"/>
           </a:solidFill>
           <a:ln/>
         </p:spPr>
       </p:sp>
-      <p:sp>
-        <p:nvSpPr>
-          <p:cNvPr id="32" name="Text 30"/>
-          <p:cNvSpPr/>
-          <p:nvPr/>
-        </p:nvSpPr>
-        <p:spPr>
-          <a:xfrm>
-            <a:off x="8171688" y="1618488"/>
+      <p:pic>
+        <p:nvPicPr>
+          <p:cNvPr id="33" name="Image 2" descr="public/logos/diamond-events.png">    </p:cNvPr>
+          <p:cNvPicPr>
+            <a:picLocks noChangeAspect="1"/>
+          </p:cNvPicPr>
+          <p:nvPr/>
+        </p:nvPicPr>
+        <p:blipFill>
+          <a:blip r:embed="rId3"/>
+          <a:stretch>
+            <a:fillRect/>
+          </a:stretch>
+        </p:blipFill>
+        <p:spPr>
+          <a:xfrm>
+            <a:off x="8808720" y="1691640"/>
+            <a:ext cx="1737360" cy="1042416"/>
+          </a:xfrm>
+          <a:prstGeom prst="rect">
+            <a:avLst/>
+          </a:prstGeom>
+        </p:spPr>
+      </p:pic>
+      <p:sp>
+        <p:nvSpPr>
+          <p:cNvPr id="34" name="Text 29"/>
+          <p:cNvSpPr/>
+          <p:nvPr/>
+        </p:nvSpPr>
+        <p:spPr>
+          <a:xfrm>
+            <a:off x="8171688" y="2816352"/>
             <a:ext cx="3011424" cy="256032"/>
           </a:xfrm>
           <a:prstGeom prst="rect">
@@ -20794,19 +21394,19 @@
           <a:bodyPr wrap="square" rtlCol="0" anchor="ctr"/>
           <a:lstStyle/>
           <a:p>
-            <a:pPr indent="0" marL="0">
+            <a:pPr algn="ctr" indent="0" marL="0">
               <a:buNone/>
             </a:pPr>
             <a:r>
               <a:rPr lang="en-US" sz="800" b="1" spc="150" kern="0" dirty="0">
                 <a:solidFill>
-                  <a:srgbClr val="38BDF8"/>
-                </a:solidFill>
-                <a:latin typeface="Segoe UI" pitchFamily="34" charset="0"/>
-                <a:ea typeface="Segoe UI" pitchFamily="34" charset="-122"/>
-                <a:cs typeface="Segoe UI" pitchFamily="34" charset="-120"/>
-              </a:rPr>
-              <a:t>EDTECH · AMMAN &amp; UAE</a:t>
+                  <a:srgbClr val="F59E0B"/>
+                </a:solidFill>
+                <a:latin typeface="Segoe UI" pitchFamily="34" charset="0"/>
+                <a:ea typeface="Segoe UI" pitchFamily="34" charset="-122"/>
+                <a:cs typeface="Segoe UI" pitchFamily="34" charset="-120"/>
+              </a:rPr>
+              <a:t>EVENTS · UAE</a:t>
             </a:r>
             <a:endParaRPr lang="en-US" sz="800" dirty="0"/>
           </a:p>
@@ -20814,33 +21414,33 @@
       </p:sp>
       <p:sp>
         <p:nvSpPr>
-          <p:cNvPr id="33" name="Text 31"/>
-          <p:cNvSpPr/>
-          <p:nvPr/>
-        </p:nvSpPr>
-        <p:spPr>
-          <a:xfrm>
-            <a:off x="8171688" y="1874520"/>
-            <a:ext cx="3011424" cy="731520"/>
-          </a:xfrm>
-          <a:prstGeom prst="rect">
-            <a:avLst/>
-          </a:prstGeom>
-          <a:noFill/>
-          <a:ln/>
-        </p:spPr>
-        <p:txBody>
-          <a:bodyPr wrap="square" rtlCol="0" anchor="ctr"/>
-          <a:lstStyle/>
-          <a:p>
-            <a:pPr indent="0" marL="0">
+          <p:cNvPr id="35" name="Text 30"/>
+          <p:cNvSpPr/>
+          <p:nvPr/>
+        </p:nvSpPr>
+        <p:spPr>
+          <a:xfrm>
+            <a:off x="8171688" y="3072384"/>
+            <a:ext cx="3011424" cy="685800"/>
+          </a:xfrm>
+          <a:prstGeom prst="rect">
+            <a:avLst/>
+          </a:prstGeom>
+          <a:noFill/>
+          <a:ln/>
+        </p:spPr>
+        <p:txBody>
+          <a:bodyPr wrap="square" rtlCol="0" anchor="ctr"/>
+          <a:lstStyle/>
+          <a:p>
+            <a:pPr algn="ctr" indent="0" marL="0">
               <a:lnSpc>
-                <a:spcPts val="1700"/>
+                <a:spcPts val="1600"/>
               </a:lnSpc>
               <a:buNone/>
             </a:pPr>
             <a:r>
-              <a:rPr lang="en-US" sz="1400" b="1" dirty="0">
+              <a:rPr lang="en-US" sz="1350" b="1" dirty="0">
                 <a:solidFill>
                   <a:srgbClr val="10232E"/>
                 </a:solidFill>
@@ -20848,41 +21448,41 @@
                 <a:ea typeface="Segoe UI" pitchFamily="34" charset="-122"/>
                 <a:cs typeface="Segoe UI" pitchFamily="34" charset="-120"/>
               </a:rPr>
-              <a:t>KidiVerse — Kids-Safe Streaming</a:t>
-            </a:r>
-            <a:endParaRPr lang="en-US" sz="1400" dirty="0"/>
-          </a:p>
-        </p:txBody>
-      </p:sp>
-      <p:sp>
-        <p:nvSpPr>
-          <p:cNvPr id="34" name="Text 32"/>
-          <p:cNvSpPr/>
-          <p:nvPr/>
-        </p:nvSpPr>
-        <p:spPr>
-          <a:xfrm>
-            <a:off x="8171688" y="2697480"/>
-            <a:ext cx="3011424" cy="1874520"/>
-          </a:xfrm>
-          <a:prstGeom prst="rect">
-            <a:avLst/>
-          </a:prstGeom>
-          <a:noFill/>
-          <a:ln/>
-        </p:spPr>
-        <p:txBody>
-          <a:bodyPr wrap="square" rtlCol="0" anchor="ctr"/>
-          <a:lstStyle/>
-          <a:p>
-            <a:pPr indent="0" marL="0">
+              <a:t>Diamond Events — Weddings &amp; Flowers</a:t>
+            </a:r>
+            <a:endParaRPr lang="en-US" sz="1350" dirty="0"/>
+          </a:p>
+        </p:txBody>
+      </p:sp>
+      <p:sp>
+        <p:nvSpPr>
+          <p:cNvPr id="36" name="Text 31"/>
+          <p:cNvSpPr/>
+          <p:nvPr/>
+        </p:nvSpPr>
+        <p:spPr>
+          <a:xfrm>
+            <a:off x="8171688" y="3803904"/>
+            <a:ext cx="3011424" cy="1600200"/>
+          </a:xfrm>
+          <a:prstGeom prst="rect">
+            <a:avLst/>
+          </a:prstGeom>
+          <a:noFill/>
+          <a:ln/>
+        </p:spPr>
+        <p:txBody>
+          <a:bodyPr wrap="square" rtlCol="0" anchor="ctr"/>
+          <a:lstStyle/>
+          <a:p>
+            <a:pPr algn="ctr" indent="0" marL="0">
               <a:lnSpc>
-                <a:spcPts val="1400"/>
+                <a:spcPts val="1300"/>
               </a:lnSpc>
               <a:buNone/>
             </a:pPr>
             <a:r>
-              <a:rPr lang="en-US" sz="1000" dirty="0">
+              <a:rPr lang="en-US" sz="950" dirty="0">
                 <a:solidFill>
                   <a:srgbClr val="3A4A56"/>
                 </a:solidFill>
@@ -20890,61 +21490,22 @@
                 <a:ea typeface="Segoe UI" pitchFamily="34" charset="-122"/>
                 <a:cs typeface="Segoe UI" pitchFamily="34" charset="-120"/>
               </a:rPr>
-              <a:t>A kids-first video streaming platform for a family media operator — curated Arabic and English content, six layers of parental controls, and a human-plus-automated content review pipeline.</a:t>
-            </a:r>
-            <a:endParaRPr lang="en-US" sz="1000" dirty="0"/>
-          </a:p>
-        </p:txBody>
-      </p:sp>
-      <p:sp>
-        <p:nvSpPr>
-          <p:cNvPr id="35" name="Text 33"/>
-          <p:cNvSpPr/>
-          <p:nvPr/>
-        </p:nvSpPr>
-        <p:spPr>
-          <a:xfrm>
-            <a:off x="8171688" y="4636008"/>
-            <a:ext cx="3011424" cy="228600"/>
-          </a:xfrm>
-          <a:prstGeom prst="rect">
-            <a:avLst/>
-          </a:prstGeom>
-          <a:noFill/>
-          <a:ln/>
-        </p:spPr>
-        <p:txBody>
-          <a:bodyPr wrap="square" rtlCol="0" anchor="ctr"/>
-          <a:lstStyle/>
-          <a:p>
-            <a:pPr indent="0" marL="0">
-              <a:buNone/>
-            </a:pPr>
-            <a:r>
-              <a:rPr lang="en-US" sz="750" b="1" spc="200" kern="0" dirty="0">
-                <a:solidFill>
-                  <a:srgbClr val="52677A"/>
-                </a:solidFill>
-                <a:latin typeface="Segoe UI" pitchFamily="34" charset="0"/>
-                <a:ea typeface="Segoe UI" pitchFamily="34" charset="-122"/>
-                <a:cs typeface="Segoe UI" pitchFamily="34" charset="-120"/>
-              </a:rPr>
-              <a:t>DELIVERED</a:t>
-            </a:r>
-            <a:endParaRPr lang="en-US" sz="750" dirty="0"/>
-          </a:p>
-        </p:txBody>
-      </p:sp>
-      <p:sp>
-        <p:nvSpPr>
-          <p:cNvPr id="36" name="Shape 34"/>
-          <p:cNvSpPr/>
-          <p:nvPr/>
-        </p:nvSpPr>
-        <p:spPr>
-          <a:xfrm>
-            <a:off x="8171688" y="4892040"/>
-            <a:ext cx="3011424" cy="292608"/>
+              <a:t>A luxury identity and digital launch for a weddings-and-flowers studio — gold-standard branding, a portfolio website with enquiry and booking flows, and an Instagram-first content system.</a:t>
+            </a:r>
+            <a:endParaRPr lang="en-US" sz="950" dirty="0"/>
+          </a:p>
+        </p:txBody>
+      </p:sp>
+      <p:sp>
+        <p:nvSpPr>
+          <p:cNvPr id="37" name="Shape 32"/>
+          <p:cNvSpPr/>
+          <p:nvPr/>
+        </p:nvSpPr>
+        <p:spPr>
+          <a:xfrm>
+            <a:off x="8263128" y="5074920"/>
+            <a:ext cx="2828544" cy="292608"/>
           </a:xfrm>
           <a:prstGeom prst="roundRect">
             <a:avLst>
@@ -20956,7 +21517,7 @@
           </a:solidFill>
           <a:ln w="9525">
             <a:solidFill>
-              <a:srgbClr val="38BDF8"/>
+              <a:srgbClr val="F59E0B"/>
             </a:solidFill>
             <a:prstDash val="solid"/>
           </a:ln>
@@ -20964,14 +21525,14 @@
       </p:sp>
       <p:sp>
         <p:nvSpPr>
-          <p:cNvPr id="37" name="Text 35"/>
-          <p:cNvSpPr/>
-          <p:nvPr/>
-        </p:nvSpPr>
-        <p:spPr>
-          <a:xfrm>
-            <a:off x="8171688" y="4884725"/>
-            <a:ext cx="3011424" cy="310896"/>
+          <p:cNvPr id="38" name="Text 33"/>
+          <p:cNvSpPr/>
+          <p:nvPr/>
+        </p:nvSpPr>
+        <p:spPr>
+          <a:xfrm>
+            <a:off x="8263128" y="5067605"/>
+            <a:ext cx="2828544" cy="310896"/>
           </a:xfrm>
           <a:prstGeom prst="rect">
             <a:avLst/>
@@ -20989,13 +21550,13 @@
             <a:r>
               <a:rPr lang="en-US" sz="850" b="1" dirty="0">
                 <a:solidFill>
-                  <a:srgbClr val="38BDF8"/>
-                </a:solidFill>
-                <a:latin typeface="Segoe UI" pitchFamily="34" charset="0"/>
-                <a:ea typeface="Segoe UI" pitchFamily="34" charset="-122"/>
-                <a:cs typeface="Segoe UI" pitchFamily="34" charset="-120"/>
-              </a:rPr>
-              <a:t>Parental controls</a:t>
+                  <a:srgbClr val="F59E0B"/>
+                </a:solidFill>
+                <a:latin typeface="Segoe UI" pitchFamily="34" charset="0"/>
+                <a:ea typeface="Segoe UI" pitchFamily="34" charset="-122"/>
+                <a:cs typeface="Segoe UI" pitchFamily="34" charset="-120"/>
+              </a:rPr>
+              <a:t>Luxury brand identity</a:t>
             </a:r>
             <a:endParaRPr lang="en-US" sz="850" dirty="0"/>
           </a:p>
@@ -21003,14 +21564,14 @@
       </p:sp>
       <p:sp>
         <p:nvSpPr>
-          <p:cNvPr id="38" name="Shape 36"/>
-          <p:cNvSpPr/>
-          <p:nvPr/>
-        </p:nvSpPr>
-        <p:spPr>
-          <a:xfrm>
-            <a:off x="8171688" y="5239512"/>
-            <a:ext cx="3011424" cy="292608"/>
+          <p:cNvPr id="39" name="Shape 34"/>
+          <p:cNvSpPr/>
+          <p:nvPr/>
+        </p:nvSpPr>
+        <p:spPr>
+          <a:xfrm>
+            <a:off x="8263128" y="5422392"/>
+            <a:ext cx="2828544" cy="292608"/>
           </a:xfrm>
           <a:prstGeom prst="roundRect">
             <a:avLst>
@@ -21022,7 +21583,7 @@
           </a:solidFill>
           <a:ln w="9525">
             <a:solidFill>
-              <a:srgbClr val="38BDF8"/>
+              <a:srgbClr val="F59E0B"/>
             </a:solidFill>
             <a:prstDash val="solid"/>
           </a:ln>
@@ -21030,14 +21591,14 @@
       </p:sp>
       <p:sp>
         <p:nvSpPr>
-          <p:cNvPr id="39" name="Text 37"/>
-          <p:cNvSpPr/>
-          <p:nvPr/>
-        </p:nvSpPr>
-        <p:spPr>
-          <a:xfrm>
-            <a:off x="8171688" y="5232197"/>
-            <a:ext cx="3011424" cy="310896"/>
+          <p:cNvPr id="40" name="Text 35"/>
+          <p:cNvSpPr/>
+          <p:nvPr/>
+        </p:nvSpPr>
+        <p:spPr>
+          <a:xfrm>
+            <a:off x="8263128" y="5415077"/>
+            <a:ext cx="2828544" cy="310896"/>
           </a:xfrm>
           <a:prstGeom prst="rect">
             <a:avLst/>
@@ -21055,13 +21616,13 @@
             <a:r>
               <a:rPr lang="en-US" sz="850" b="1" dirty="0">
                 <a:solidFill>
-                  <a:srgbClr val="38BDF8"/>
-                </a:solidFill>
-                <a:latin typeface="Segoe UI" pitchFamily="34" charset="0"/>
-                <a:ea typeface="Segoe UI" pitchFamily="34" charset="-122"/>
-                <a:cs typeface="Segoe UI" pitchFamily="34" charset="-120"/>
-              </a:rPr>
-              <a:t>Content pipeline</a:t>
+                  <a:srgbClr val="F59E0B"/>
+                </a:solidFill>
+                <a:latin typeface="Segoe UI" pitchFamily="34" charset="0"/>
+                <a:ea typeface="Segoe UI" pitchFamily="34" charset="-122"/>
+                <a:cs typeface="Segoe UI" pitchFamily="34" charset="-120"/>
+              </a:rPr>
+              <a:t>Booking website</a:t>
             </a:r>
             <a:endParaRPr lang="en-US" sz="850" dirty="0"/>
           </a:p>
@@ -21069,14 +21630,14 @@
       </p:sp>
       <p:sp>
         <p:nvSpPr>
-          <p:cNvPr id="40" name="Shape 38"/>
-          <p:cNvSpPr/>
-          <p:nvPr/>
-        </p:nvSpPr>
-        <p:spPr>
-          <a:xfrm>
-            <a:off x="8171688" y="5586984"/>
-            <a:ext cx="3011424" cy="292608"/>
+          <p:cNvPr id="41" name="Shape 36"/>
+          <p:cNvSpPr/>
+          <p:nvPr/>
+        </p:nvSpPr>
+        <p:spPr>
+          <a:xfrm>
+            <a:off x="8263128" y="5769864"/>
+            <a:ext cx="2828544" cy="292608"/>
           </a:xfrm>
           <a:prstGeom prst="roundRect">
             <a:avLst>
@@ -21088,7 +21649,7 @@
           </a:solidFill>
           <a:ln w="9525">
             <a:solidFill>
-              <a:srgbClr val="38BDF8"/>
+              <a:srgbClr val="F59E0B"/>
             </a:solidFill>
             <a:prstDash val="solid"/>
           </a:ln>
@@ -21096,14 +21657,14 @@
       </p:sp>
       <p:sp>
         <p:nvSpPr>
-          <p:cNvPr id="41" name="Text 39"/>
-          <p:cNvSpPr/>
-          <p:nvPr/>
-        </p:nvSpPr>
-        <p:spPr>
-          <a:xfrm>
-            <a:off x="8171688" y="5579669"/>
-            <a:ext cx="3011424" cy="310896"/>
+          <p:cNvPr id="42" name="Text 37"/>
+          <p:cNvSpPr/>
+          <p:nvPr/>
+        </p:nvSpPr>
+        <p:spPr>
+          <a:xfrm>
+            <a:off x="8263128" y="5762549"/>
+            <a:ext cx="2828544" cy="310896"/>
           </a:xfrm>
           <a:prstGeom prst="rect">
             <a:avLst/>
@@ -21121,13 +21682,13 @@
             <a:r>
               <a:rPr lang="en-US" sz="850" b="1" dirty="0">
                 <a:solidFill>
-                  <a:srgbClr val="38BDF8"/>
-                </a:solidFill>
-                <a:latin typeface="Segoe UI" pitchFamily="34" charset="0"/>
-                <a:ea typeface="Segoe UI" pitchFamily="34" charset="-122"/>
-                <a:cs typeface="Segoe UI" pitchFamily="34" charset="-120"/>
-              </a:rPr>
-              <a:t>AR/EN library</a:t>
+                  <a:srgbClr val="F59E0B"/>
+                </a:solidFill>
+                <a:latin typeface="Segoe UI" pitchFamily="34" charset="0"/>
+                <a:ea typeface="Segoe UI" pitchFamily="34" charset="-122"/>
+                <a:cs typeface="Segoe UI" pitchFamily="34" charset="-120"/>
+              </a:rPr>
+              <a:t>Content system</a:t>
             </a:r>
             <a:endParaRPr lang="en-US" sz="850" dirty="0"/>
           </a:p>
@@ -21135,7 +21696,7 @@
       </p:sp>
       <p:sp>
         <p:nvSpPr>
-          <p:cNvPr id="42" name="Text 40"/>
+          <p:cNvPr id="43" name="Text 38"/>
           <p:cNvSpPr/>
           <p:nvPr/>
         </p:nvSpPr>
@@ -21188,7 +21749,7 @@
       </p:sp>
       <p:sp>
         <p:nvSpPr>
-          <p:cNvPr id="43" name="Text 41"/>
+          <p:cNvPr id="44" name="Text 39"/>
           <p:cNvSpPr/>
           <p:nvPr/>
         </p:nvSpPr>

</xml_diff>

<commit_message>
Use real WeThink office photo as company profile cover
Adds public/profile-assets/office.jpg (compressed to 224KB) and swaps
the brand-only cover for the reference-style photo cover: full-bleed
office shot with the wall logo as hero, graduated scrim, and the
title block bottom-left with vertical rule.

https://claude.ai/code/session_01ULuS7zriwA4qk6vRYb8xau
</commit_message>
<xml_diff>
--- a/public/WeThink-Company-Profile-2026.pptx
+++ b/public/WeThink-Company-Profile-2026.pptx
@@ -2045,84 +2045,9 @@
           <a:ln/>
         </p:spPr>
       </p:sp>
-      <p:sp>
-        <p:nvSpPr>
-          <p:cNvPr id="3" name="Shape 1"/>
-          <p:cNvSpPr/>
-          <p:nvPr/>
-        </p:nvSpPr>
-        <p:spPr>
-          <a:xfrm>
-            <a:off x="-2286000" y="-2560320"/>
-            <a:ext cx="6858000" cy="6858000"/>
-          </a:xfrm>
-          <a:prstGeom prst="ellipse">
-            <a:avLst/>
-          </a:prstGeom>
-          <a:solidFill>
-            <a:srgbClr val="14B8A6">
-              <a:alpha val="12000"/>
-            </a:srgbClr>
-          </a:solidFill>
-          <a:ln w="12700">
-            <a:solidFill>
-              <a:srgbClr val="333333">
-                <a:alpha val="0"/>
-              </a:srgbClr>
-            </a:solidFill>
-            <a:prstDash val="solid"/>
-          </a:ln>
-        </p:spPr>
-      </p:sp>
-      <p:sp>
-        <p:nvSpPr>
-          <p:cNvPr id="4" name="Shape 2"/>
-          <p:cNvSpPr/>
-          <p:nvPr/>
-        </p:nvSpPr>
-        <p:spPr>
-          <a:xfrm>
-            <a:off x="8229600" y="2560320"/>
-            <a:ext cx="7315200" cy="7315200"/>
-          </a:xfrm>
-          <a:prstGeom prst="ellipse">
-            <a:avLst/>
-          </a:prstGeom>
-          <a:solidFill>
-            <a:srgbClr val="7C3AED">
-              <a:alpha val="12000"/>
-            </a:srgbClr>
-          </a:solidFill>
-          <a:ln w="12700">
-            <a:solidFill>
-              <a:srgbClr val="333333">
-                <a:alpha val="0"/>
-              </a:srgbClr>
-            </a:solidFill>
-            <a:prstDash val="solid"/>
-          </a:ln>
-        </p:spPr>
-      </p:sp>
-      <p:sp>
-        <p:nvSpPr>
-          <p:cNvPr id="5" name="Shape 3"/>
-          <p:cNvSpPr/>
-          <p:nvPr/>
-        </p:nvSpPr>
-        <p:spPr>
-          <a:xfrm>
-            <a:off x="0" y="0"/>
-            <a:ext cx="12192000" cy="82296"/>
-          </a:xfrm>
-          <a:prstGeom prst="rect">
-            <a:avLst/>
-          </a:prstGeom>
-          <a:ln/>
-        </p:spPr>
-      </p:sp>
       <p:pic>
         <p:nvPicPr>
-          <p:cNvPr id="6" name="Image 0" descr="public/logo.png">    </p:cNvPr>
+          <p:cNvPr id="3" name="Image 0" descr="public/profile-assets/office.jpg">    </p:cNvPr>
           <p:cNvPicPr>
             <a:picLocks noChangeAspect="1"/>
           </p:cNvPicPr>
@@ -2130,14 +2055,98 @@
         </p:nvPicPr>
         <p:blipFill>
           <a:blip r:embed="rId1"/>
+          <a:srcRect l="0" r="0" t="0" b="0"/>
+          <a:stretch/>
+        </p:blipFill>
+        <p:spPr>
+          <a:xfrm>
+            <a:off x="0" y="0"/>
+            <a:ext cx="12188952" cy="6858000"/>
+          </a:xfrm>
+          <a:prstGeom prst="rect">
+            <a:avLst/>
+          </a:prstGeom>
+        </p:spPr>
+      </p:pic>
+      <p:sp>
+        <p:nvSpPr>
+          <p:cNvPr id="4" name="Shape 1"/>
+          <p:cNvSpPr/>
+          <p:nvPr/>
+        </p:nvSpPr>
+        <p:spPr>
+          <a:xfrm>
+            <a:off x="0" y="0"/>
+            <a:ext cx="12192000" cy="6858000"/>
+          </a:xfrm>
+          <a:prstGeom prst="rect">
+            <a:avLst/>
+          </a:prstGeom>
+          <a:solidFill>
+            <a:srgbClr val="0A1D21">
+              <a:alpha val="38000"/>
+            </a:srgbClr>
+          </a:solidFill>
+          <a:ln/>
+        </p:spPr>
+      </p:sp>
+      <p:sp>
+        <p:nvSpPr>
+          <p:cNvPr id="5" name="Shape 2"/>
+          <p:cNvSpPr/>
+          <p:nvPr/>
+        </p:nvSpPr>
+        <p:spPr>
+          <a:xfrm>
+            <a:off x="0" y="3749040"/>
+            <a:ext cx="12192000" cy="3108960"/>
+          </a:xfrm>
+          <a:prstGeom prst="rect">
+            <a:avLst/>
+          </a:prstGeom>
+          <a:solidFill>
+            <a:srgbClr val="0A1D21">
+              <a:alpha val="62000"/>
+            </a:srgbClr>
+          </a:solidFill>
+          <a:ln/>
+        </p:spPr>
+      </p:sp>
+      <p:sp>
+        <p:nvSpPr>
+          <p:cNvPr id="6" name="Shape 3"/>
+          <p:cNvSpPr/>
+          <p:nvPr/>
+        </p:nvSpPr>
+        <p:spPr>
+          <a:xfrm>
+            <a:off x="0" y="0"/>
+            <a:ext cx="12192000" cy="82296"/>
+          </a:xfrm>
+          <a:prstGeom prst="rect">
+            <a:avLst/>
+          </a:prstGeom>
+          <a:ln/>
+        </p:spPr>
+      </p:sp>
+      <p:pic>
+        <p:nvPicPr>
+          <p:cNvPr id="7" name="Image 1" descr="public/logo.png">    </p:cNvPr>
+          <p:cNvPicPr>
+            <a:picLocks noChangeAspect="1"/>
+          </p:cNvPicPr>
+          <p:nvPr/>
+        </p:nvPicPr>
+        <p:blipFill>
+          <a:blip r:embed="rId2"/>
           <a:stretch>
             <a:fillRect/>
           </a:stretch>
         </p:blipFill>
         <p:spPr>
           <a:xfrm>
-            <a:off x="5408676" y="1051560"/>
-            <a:ext cx="1371600" cy="1371600"/>
+            <a:off x="548640" y="411480"/>
+            <a:ext cx="546811" cy="546811"/>
           </a:xfrm>
           <a:prstGeom prst="rect">
             <a:avLst/>
@@ -2146,30 +2155,30 @@
       </p:pic>
       <p:sp>
         <p:nvSpPr>
-          <p:cNvPr id="7" name="Text 4"/>
-          <p:cNvSpPr/>
-          <p:nvPr/>
-        </p:nvSpPr>
-        <p:spPr>
-          <a:xfrm>
-            <a:off x="0" y="2514600"/>
-            <a:ext cx="12188952" cy="640080"/>
-          </a:xfrm>
-          <a:prstGeom prst="rect">
-            <a:avLst/>
-          </a:prstGeom>
-          <a:noFill/>
-          <a:ln/>
-        </p:spPr>
-        <p:txBody>
-          <a:bodyPr wrap="square" rtlCol="0" anchor="ctr"/>
-          <a:lstStyle/>
-          <a:p>
-            <a:pPr algn="ctr" indent="0" marL="0">
-              <a:buNone/>
-            </a:pPr>
-            <a:r>
-              <a:rPr lang="en-US" sz="4000" b="1" dirty="0">
+          <p:cNvPr id="8" name="Text 4"/>
+          <p:cNvSpPr/>
+          <p:nvPr/>
+        </p:nvSpPr>
+        <p:spPr>
+          <a:xfrm>
+            <a:off x="1126998" y="369418"/>
+            <a:ext cx="1892808" cy="420624"/>
+          </a:xfrm>
+          <a:prstGeom prst="rect">
+            <a:avLst/>
+          </a:prstGeom>
+          <a:noFill/>
+          <a:ln/>
+        </p:spPr>
+        <p:txBody>
+          <a:bodyPr wrap="square" rtlCol="0" anchor="ctr"/>
+          <a:lstStyle/>
+          <a:p>
+            <a:pPr indent="0" marL="0">
+              <a:buNone/>
+            </a:pPr>
+            <a:r>
+              <a:rPr lang="en-US" sz="1955" b="1" dirty="0">
                 <a:solidFill>
                   <a:srgbClr val="FFFFFF"/>
                 </a:solidFill>
@@ -2179,11 +2188,11 @@
               </a:rPr>
               <a:t>We</a:t>
             </a:r>
-            <a:pPr algn="ctr" indent="0" marL="0">
-              <a:buNone/>
-            </a:pPr>
-            <a:r>
-              <a:rPr lang="en-US" sz="4000" b="1" dirty="0">
+            <a:pPr indent="0" marL="0">
+              <a:buNone/>
+            </a:pPr>
+            <a:r>
+              <a:rPr lang="en-US" sz="1955" b="1" dirty="0">
                 <a:solidFill>
                   <a:srgbClr val="8B5CF6"/>
                 </a:solidFill>
@@ -2193,92 +2202,100 @@
               </a:rPr>
               <a:t>Think</a:t>
             </a:r>
-            <a:endParaRPr lang="en-US" sz="4000" dirty="0"/>
-          </a:p>
-        </p:txBody>
-      </p:sp>
-      <p:sp>
-        <p:nvSpPr>
-          <p:cNvPr id="8" name="Text 5"/>
-          <p:cNvSpPr/>
-          <p:nvPr/>
-        </p:nvSpPr>
-        <p:spPr>
-          <a:xfrm>
-            <a:off x="0" y="3200400"/>
-            <a:ext cx="12188952" cy="320040"/>
-          </a:xfrm>
-          <a:prstGeom prst="rect">
-            <a:avLst/>
-          </a:prstGeom>
-          <a:noFill/>
-          <a:ln/>
-        </p:spPr>
-        <p:txBody>
-          <a:bodyPr wrap="square" rtlCol="0" anchor="ctr"/>
-          <a:lstStyle/>
-          <a:p>
-            <a:pPr algn="ctr" indent="0" marL="0">
-              <a:buNone/>
-            </a:pPr>
-            <a:r>
-              <a:rPr lang="en-US" sz="1100" spc="200" kern="0" dirty="0">
-                <a:solidFill>
-                  <a:srgbClr val="14B8A6"/>
-                </a:solidFill>
-                <a:latin typeface="Segoe UI" pitchFamily="34" charset="0"/>
-                <a:ea typeface="Segoe UI" pitchFamily="34" charset="-122"/>
-                <a:cs typeface="Segoe UI" pitchFamily="34" charset="-120"/>
-              </a:rPr>
-              <a:t>T H I N K   ·   P L A N   ·   G R O W</a:t>
-            </a:r>
-            <a:endParaRPr lang="en-US" sz="1100" dirty="0"/>
-          </a:p>
-        </p:txBody>
-      </p:sp>
-      <p:sp>
-        <p:nvSpPr>
-          <p:cNvPr id="9" name="Shape 6"/>
-          <p:cNvSpPr/>
-          <p:nvPr/>
-        </p:nvSpPr>
-        <p:spPr>
-          <a:xfrm>
-            <a:off x="5637276" y="3703320"/>
-            <a:ext cx="914400" cy="41148"/>
-          </a:xfrm>
-          <a:prstGeom prst="rect">
-            <a:avLst/>
-          </a:prstGeom>
-          <a:ln/>
-        </p:spPr>
-      </p:sp>
-      <p:sp>
-        <p:nvSpPr>
-          <p:cNvPr id="10" name="Text 7"/>
-          <p:cNvSpPr/>
-          <p:nvPr/>
-        </p:nvSpPr>
-        <p:spPr>
-          <a:xfrm>
-            <a:off x="0" y="3886200"/>
-            <a:ext cx="12188952" cy="777240"/>
-          </a:xfrm>
-          <a:prstGeom prst="rect">
-            <a:avLst/>
-          </a:prstGeom>
-          <a:noFill/>
-          <a:ln/>
-        </p:spPr>
-        <p:txBody>
-          <a:bodyPr wrap="square" rtlCol="0" anchor="ctr"/>
-          <a:lstStyle/>
-          <a:p>
-            <a:pPr algn="ctr" indent="0" marL="0">
-              <a:buNone/>
-            </a:pPr>
-            <a:r>
-              <a:rPr lang="en-US" sz="4400" b="1" dirty="0">
+            <a:endParaRPr lang="en-US" sz="1955" dirty="0"/>
+          </a:p>
+        </p:txBody>
+      </p:sp>
+      <p:sp>
+        <p:nvSpPr>
+          <p:cNvPr id="9" name="Text 5"/>
+          <p:cNvSpPr/>
+          <p:nvPr/>
+        </p:nvSpPr>
+        <p:spPr>
+          <a:xfrm>
+            <a:off x="1148029" y="726948"/>
+            <a:ext cx="2103120" cy="252374"/>
+          </a:xfrm>
+          <a:prstGeom prst="rect">
+            <a:avLst/>
+          </a:prstGeom>
+          <a:noFill/>
+          <a:ln/>
+        </p:spPr>
+        <p:txBody>
+          <a:bodyPr wrap="square" rtlCol="0" anchor="ctr"/>
+          <a:lstStyle/>
+          <a:p>
+            <a:pPr indent="0" marL="0">
+              <a:buNone/>
+            </a:pPr>
+            <a:r>
+              <a:rPr lang="en-US" sz="748" spc="300" kern="0" dirty="0">
+                <a:solidFill>
+                  <a:srgbClr val="9FB8B4"/>
+                </a:solidFill>
+                <a:latin typeface="Segoe UI" pitchFamily="34" charset="0"/>
+                <a:ea typeface="Segoe UI" pitchFamily="34" charset="-122"/>
+                <a:cs typeface="Segoe UI" pitchFamily="34" charset="-120"/>
+              </a:rPr>
+              <a:t>THINK · PLAN · GROW</a:t>
+            </a:r>
+            <a:endParaRPr lang="en-US" sz="748" dirty="0"/>
+          </a:p>
+        </p:txBody>
+      </p:sp>
+      <p:sp>
+        <p:nvSpPr>
+          <p:cNvPr id="10" name="Shape 6"/>
+          <p:cNvSpPr/>
+          <p:nvPr/>
+        </p:nvSpPr>
+        <p:spPr>
+          <a:xfrm>
+            <a:off x="960120" y="4069080"/>
+            <a:ext cx="25603" cy="1783080"/>
+          </a:xfrm>
+          <a:prstGeom prst="rect">
+            <a:avLst/>
+          </a:prstGeom>
+          <a:solidFill>
+            <a:srgbClr val="FFFFFF">
+              <a:alpha val="70000"/>
+            </a:srgbClr>
+          </a:solidFill>
+          <a:ln/>
+        </p:spPr>
+      </p:sp>
+      <p:sp>
+        <p:nvSpPr>
+          <p:cNvPr id="11" name="Text 7"/>
+          <p:cNvSpPr/>
+          <p:nvPr/>
+        </p:nvSpPr>
+        <p:spPr>
+          <a:xfrm>
+            <a:off x="1234440" y="3977640"/>
+            <a:ext cx="6858000" cy="1463040"/>
+          </a:xfrm>
+          <a:prstGeom prst="rect">
+            <a:avLst/>
+          </a:prstGeom>
+          <a:noFill/>
+          <a:ln/>
+        </p:spPr>
+        <p:txBody>
+          <a:bodyPr wrap="square" rtlCol="0" anchor="ctr"/>
+          <a:lstStyle/>
+          <a:p>
+            <a:pPr indent="0" marL="0">
+              <a:lnSpc>
+                <a:spcPts val="4800"/>
+              </a:lnSpc>
+              <a:buNone/>
+            </a:pPr>
+            <a:r>
+              <a:rPr lang="en-US" sz="4200" b="1" dirty="0">
                 <a:solidFill>
                   <a:srgbClr val="FFFFFF"/>
                 </a:solidFill>
@@ -2286,38 +2303,114 @@
                 <a:ea typeface="Segoe UI" pitchFamily="34" charset="-122"/>
                 <a:cs typeface="Segoe UI" pitchFamily="34" charset="-120"/>
               </a:rPr>
-              <a:t>Company Profile</a:t>
-            </a:r>
-            <a:endParaRPr lang="en-US" sz="4400" dirty="0"/>
-          </a:p>
-        </p:txBody>
-      </p:sp>
-      <p:sp>
-        <p:nvSpPr>
-          <p:cNvPr id="11" name="Text 8"/>
-          <p:cNvSpPr/>
-          <p:nvPr/>
-        </p:nvSpPr>
-        <p:spPr>
-          <a:xfrm>
-            <a:off x="0" y="4709160"/>
-            <a:ext cx="12188952" cy="411480"/>
-          </a:xfrm>
-          <a:prstGeom prst="rect">
-            <a:avLst/>
-          </a:prstGeom>
-          <a:noFill/>
-          <a:ln/>
-        </p:spPr>
-        <p:txBody>
-          <a:bodyPr wrap="square" rtlCol="0" anchor="ctr"/>
-          <a:lstStyle/>
-          <a:p>
-            <a:pPr algn="ctr" indent="0" marL="0">
-              <a:buNone/>
-            </a:pPr>
-            <a:r>
-              <a:rPr lang="en-US" sz="1700" dirty="0">
+              <a:t>Company</a:t>
+            </a:r>
+            <a:endParaRPr lang="en-US" sz="4200" dirty="0"/>
+          </a:p>
+          <a:p>
+            <a:pPr indent="0" marL="0">
+              <a:lnSpc>
+                <a:spcPts val="4800"/>
+              </a:lnSpc>
+              <a:buNone/>
+            </a:pPr>
+            <a:r>
+              <a:rPr lang="en-US" sz="4200" b="1" dirty="0">
+                <a:solidFill>
+                  <a:srgbClr val="FFFFFF"/>
+                </a:solidFill>
+                <a:latin typeface="Segoe UI" pitchFamily="34" charset="0"/>
+                <a:ea typeface="Segoe UI" pitchFamily="34" charset="-122"/>
+                <a:cs typeface="Segoe UI" pitchFamily="34" charset="-120"/>
+              </a:rPr>
+              <a:t>Profile</a:t>
+            </a:r>
+            <a:endParaRPr lang="en-US" sz="4200" dirty="0"/>
+          </a:p>
+        </p:txBody>
+      </p:sp>
+      <p:sp>
+        <p:nvSpPr>
+          <p:cNvPr id="12" name="Shape 8"/>
+          <p:cNvSpPr/>
+          <p:nvPr/>
+        </p:nvSpPr>
+        <p:spPr>
+          <a:xfrm>
+            <a:off x="1261872" y="5504688"/>
+            <a:ext cx="128016" cy="365760"/>
+          </a:xfrm>
+          <a:prstGeom prst="rect">
+            <a:avLst/>
+          </a:prstGeom>
+          <a:ln/>
+        </p:spPr>
+      </p:sp>
+      <p:sp>
+        <p:nvSpPr>
+          <p:cNvPr id="13" name="Text 9"/>
+          <p:cNvSpPr/>
+          <p:nvPr/>
+        </p:nvSpPr>
+        <p:spPr>
+          <a:xfrm>
+            <a:off x="1481328" y="5468112"/>
+            <a:ext cx="7772400" cy="384048"/>
+          </a:xfrm>
+          <a:prstGeom prst="rect">
+            <a:avLst/>
+          </a:prstGeom>
+          <a:noFill/>
+          <a:ln/>
+        </p:spPr>
+        <p:txBody>
+          <a:bodyPr wrap="square" rtlCol="0" anchor="ctr"/>
+          <a:lstStyle/>
+          <a:p>
+            <a:pPr indent="0" marL="0">
+              <a:buNone/>
+            </a:pPr>
+            <a:r>
+              <a:rPr lang="en-US" sz="1800" dirty="0">
+                <a:solidFill>
+                  <a:srgbClr val="FFFFFF"/>
+                </a:solidFill>
+                <a:latin typeface="Segoe UI" pitchFamily="34" charset="0"/>
+                <a:ea typeface="Segoe UI" pitchFamily="34" charset="-122"/>
+                <a:cs typeface="Segoe UI" pitchFamily="34" charset="-120"/>
+              </a:rPr>
+              <a:t>Your Digital Transformation Partner</a:t>
+            </a:r>
+            <a:endParaRPr lang="en-US" sz="1800" dirty="0"/>
+          </a:p>
+        </p:txBody>
+      </p:sp>
+      <p:sp>
+        <p:nvSpPr>
+          <p:cNvPr id="14" name="Text 10"/>
+          <p:cNvSpPr/>
+          <p:nvPr/>
+        </p:nvSpPr>
+        <p:spPr>
+          <a:xfrm>
+            <a:off x="1481328" y="5870448"/>
+            <a:ext cx="8686800" cy="301752"/>
+          </a:xfrm>
+          <a:prstGeom prst="rect">
+            <a:avLst/>
+          </a:prstGeom>
+          <a:noFill/>
+          <a:ln/>
+        </p:spPr>
+        <p:txBody>
+          <a:bodyPr wrap="square" rtlCol="0" anchor="ctr"/>
+          <a:lstStyle/>
+          <a:p>
+            <a:pPr indent="0" marL="0">
+              <a:buNone/>
+            </a:pPr>
+            <a:r>
+              <a:rPr lang="en-US" sz="1150" dirty="0">
                 <a:solidFill>
                   <a:srgbClr val="D9E6E4"/>
                 </a:solidFill>
@@ -2325,77 +2418,38 @@
                 <a:ea typeface="Segoe UI" pitchFamily="34" charset="-122"/>
                 <a:cs typeface="Segoe UI" pitchFamily="34" charset="-120"/>
               </a:rPr>
-              <a:t>Your Digital Transformation Partner</a:t>
-            </a:r>
-            <a:endParaRPr lang="en-US" sz="1700" dirty="0"/>
-          </a:p>
-        </p:txBody>
-      </p:sp>
-      <p:sp>
-        <p:nvSpPr>
-          <p:cNvPr id="12" name="Text 9"/>
-          <p:cNvSpPr/>
-          <p:nvPr/>
-        </p:nvSpPr>
-        <p:spPr>
-          <a:xfrm>
-            <a:off x="0" y="5138928"/>
-            <a:ext cx="12188952" cy="320040"/>
-          </a:xfrm>
-          <a:prstGeom prst="rect">
-            <a:avLst/>
-          </a:prstGeom>
-          <a:noFill/>
-          <a:ln/>
-        </p:spPr>
-        <p:txBody>
-          <a:bodyPr wrap="square" rtlCol="0" anchor="ctr"/>
-          <a:lstStyle/>
-          <a:p>
-            <a:pPr algn="ctr" indent="0" marL="0">
-              <a:buNone/>
-            </a:pPr>
-            <a:r>
-              <a:rPr lang="en-US" sz="1200" dirty="0">
-                <a:solidFill>
-                  <a:srgbClr val="9FB8B4"/>
-                </a:solidFill>
-                <a:latin typeface="Segoe UI" pitchFamily="34" charset="0"/>
-                <a:ea typeface="Segoe UI" pitchFamily="34" charset="-122"/>
-                <a:cs typeface="Segoe UI" pitchFamily="34" charset="-120"/>
-              </a:rPr>
               <a:t>Consulting  –  Cloud  –  Cybersecurity  –  Custom Software  –  Data &amp; AI</a:t>
             </a:r>
-            <a:endParaRPr lang="en-US" sz="1200" dirty="0"/>
-          </a:p>
-        </p:txBody>
-      </p:sp>
-      <p:sp>
-        <p:nvSpPr>
-          <p:cNvPr id="13" name="Text 10"/>
-          <p:cNvSpPr/>
-          <p:nvPr/>
-        </p:nvSpPr>
-        <p:spPr>
-          <a:xfrm>
-            <a:off x="548640" y="6309360"/>
-            <a:ext cx="8229600" cy="320040"/>
-          </a:xfrm>
-          <a:prstGeom prst="rect">
-            <a:avLst/>
-          </a:prstGeom>
-          <a:noFill/>
-          <a:ln/>
-        </p:spPr>
-        <p:txBody>
-          <a:bodyPr wrap="square" rtlCol="0" anchor="ctr"/>
-          <a:lstStyle/>
-          <a:p>
-            <a:pPr indent="0" marL="0">
-              <a:buNone/>
-            </a:pPr>
-            <a:r>
-              <a:rPr lang="en-US" sz="1050" dirty="0">
+            <a:endParaRPr lang="en-US" sz="1150" dirty="0"/>
+          </a:p>
+        </p:txBody>
+      </p:sp>
+      <p:sp>
+        <p:nvSpPr>
+          <p:cNvPr id="15" name="Text 11"/>
+          <p:cNvSpPr/>
+          <p:nvPr/>
+        </p:nvSpPr>
+        <p:spPr>
+          <a:xfrm>
+            <a:off x="548640" y="6419088"/>
+            <a:ext cx="8229600" cy="292608"/>
+          </a:xfrm>
+          <a:prstGeom prst="rect">
+            <a:avLst/>
+          </a:prstGeom>
+          <a:noFill/>
+          <a:ln/>
+        </p:spPr>
+        <p:txBody>
+          <a:bodyPr wrap="square" rtlCol="0" anchor="ctr"/>
+          <a:lstStyle/>
+          <a:p>
+            <a:pPr indent="0" marL="0">
+              <a:buNone/>
+            </a:pPr>
+            <a:r>
+              <a:rPr lang="en-US" sz="1000" dirty="0">
                 <a:solidFill>
                   <a:srgbClr val="D9E6E4"/>
                 </a:solidFill>
@@ -2405,19 +2459,19 @@
               </a:rPr>
               <a:t>Abu Dhabi, United Arab Emirates  ·  Est. 2019  ·  wethink.ae</a:t>
             </a:r>
-            <a:endParaRPr lang="en-US" sz="1050" dirty="0"/>
-          </a:p>
-        </p:txBody>
-      </p:sp>
-      <p:sp>
-        <p:nvSpPr>
-          <p:cNvPr id="14" name="Text 11"/>
-          <p:cNvSpPr/>
-          <p:nvPr/>
-        </p:nvSpPr>
-        <p:spPr>
-          <a:xfrm>
-            <a:off x="10543032" y="6236208"/>
+            <a:endParaRPr lang="en-US" sz="1000" dirty="0"/>
+          </a:p>
+        </p:txBody>
+      </p:sp>
+      <p:sp>
+        <p:nvSpPr>
+          <p:cNvPr id="16" name="Text 12"/>
+          <p:cNvSpPr/>
+          <p:nvPr/>
+        </p:nvSpPr>
+        <p:spPr>
+          <a:xfrm>
+            <a:off x="10543032" y="6309360"/>
             <a:ext cx="1097280" cy="411480"/>
           </a:xfrm>
           <a:prstGeom prst="rect">

</xml_diff>

<commit_message>
Correct Albina Alareeq to contracting company in case study and profile
The client is Albina Alareeq Contracting & General Maintenance, not a
"digital hub" — retitled the website case study and the featured case
in the company profile, and named the company fully in both
descriptions. Tightened the deck card copy so nothing clips.

https://claude.ai/code/session_01ULuS7zriwA4qk6vRYb8xau
</commit_message>
<xml_diff>
--- a/public/WeThink-Company-Profile-2026.pptx
+++ b/public/WeThink-Company-Profile-2026.pptx
@@ -20676,7 +20676,7 @@
                 <a:ea typeface="Segoe UI" pitchFamily="34" charset="-122"/>
                 <a:cs typeface="Segoe UI" pitchFamily="34" charset="-120"/>
               </a:rPr>
-              <a:t>CONSTRUCTION · ABU DHABI</a:t>
+              <a:t>CONTRACTING · ABU DHABI</a:t>
             </a:r>
             <a:endParaRPr lang="en-US" sz="800" dirty="0"/>
           </a:p>
@@ -20718,7 +20718,7 @@
                 <a:ea typeface="Segoe UI" pitchFamily="34" charset="-122"/>
                 <a:cs typeface="Segoe UI" pitchFamily="34" charset="-120"/>
               </a:rPr>
-              <a:t>Albina Alareeq Digital Hub</a:t>
+              <a:t>Albina Alareeq Contracting — Digital Transformation</a:t>
             </a:r>
             <a:endParaRPr lang="en-US" sz="1350" dirty="0"/>
           </a:p>
@@ -20760,7 +20760,7 @@
                 <a:ea typeface="Segoe UI" pitchFamily="34" charset="-122"/>
                 <a:cs typeface="Segoe UI" pitchFamily="34" charset="-120"/>
               </a:rPr>
-              <a:t>End-to-end digital transformation for a major Abu Dhabi contracting firm — a brand-aligned corporate website plus a connected project-management portal unifying field reporting and head-office visibility.</a:t>
+              <a:t>Digital transformation for Albina Alareeq Contracting &amp; General Maintenance — a corporate website plus a project-management portal unifying field reporting and head-office visibility.</a:t>
             </a:r>
             <a:endParaRPr lang="en-US" sz="950" dirty="0"/>
           </a:p>

</xml_diff>